<commit_message>
Add VirtualBox and Kali Linux pages.
</commit_message>
<xml_diff>
--- a/ACT AdvancedWireless 2026 - Setup.pptx
+++ b/ACT AdvancedWireless 2026 - Setup.pptx
@@ -5,19 +5,21 @@
     <p:sldMasterId id="2147483702" r:id="rId5"/>
   </p:sldMasterIdLst>
   <p:notesMasterIdLst>
-    <p:notesMasterId r:id="rId11"/>
+    <p:notesMasterId r:id="rId13"/>
   </p:notesMasterIdLst>
   <p:sldIdLst>
-    <p:sldId id="507" r:id="rId6"/>
-    <p:sldId id="506" r:id="rId7"/>
-    <p:sldId id="312" r:id="rId8"/>
-    <p:sldId id="310" r:id="rId9"/>
-    <p:sldId id="311" r:id="rId10"/>
+    <p:sldId id="506" r:id="rId6"/>
+    <p:sldId id="508" r:id="rId7"/>
+    <p:sldId id="509" r:id="rId8"/>
+    <p:sldId id="507" r:id="rId9"/>
+    <p:sldId id="312" r:id="rId10"/>
+    <p:sldId id="310" r:id="rId11"/>
+    <p:sldId id="311" r:id="rId12"/>
   </p:sldIdLst>
   <p:sldSz cx="12192000" cy="6858000"/>
   <p:notesSz cx="6858000" cy="9144000"/>
   <p:custDataLst>
-    <p:tags r:id="rId12"/>
+    <p:tags r:id="rId14"/>
   </p:custDataLst>
   <p:defaultTextStyle>
     <a:defPPr>
@@ -119,15 +121,23 @@
       <p14:sectionLst xmlns:p14="http://schemas.microsoft.com/office/powerpoint/2010/main">
         <p14:section name="Setup" id="{40EEF03E-46C1-4B91-8015-EA960149133A}">
           <p14:sldIdLst>
-            <p14:sldId id="507"/>
             <p14:sldId id="506"/>
           </p14:sldIdLst>
         </p14:section>
         <p14:section name="Virtual Box" id="{CAC26D38-A0B5-405B-8045-57259533A223}">
-          <p14:sldIdLst/>
+          <p14:sldIdLst>
+            <p14:sldId id="508"/>
+          </p14:sldIdLst>
         </p14:section>
-        <p14:section name="Kali Linux" id="{A31229EC-853B-4205-8E31-6B44F371A12E}">
-          <p14:sldIdLst/>
+        <p14:section name="Kali Linux" id="{AF6FF401-F398-49CD-982E-520170691C75}">
+          <p14:sldIdLst>
+            <p14:sldId id="509"/>
+          </p14:sldIdLst>
+        </p14:section>
+        <p14:section name="Syllabus" id="{A31229EC-853B-4205-8E31-6B44F371A12E}">
+          <p14:sldIdLst>
+            <p14:sldId id="507"/>
+          </p14:sldIdLst>
         </p14:section>
         <p14:section name="FCC ID" id="{996098ED-F625-41E8-8BD8-06E6CC46322C}">
           <p14:sldIdLst>
@@ -5046,7 +5056,7 @@
           <a:p>
             <a:fld id="{2FC2648E-2733-4EC8-BEDA-1577DE2D3D01}" type="datetimeFigureOut">
               <a:rPr lang="en-US" smtClean="0"/>
-              <a:t>4/29/2026</a:t>
+              <a:t>8/10/2026</a:t>
             </a:fld>
             <a:endParaRPr lang="en-US"/>
           </a:p>
@@ -5353,7 +5363,7 @@
           <a:p>
             <a:fld id="{8CF61943-3342-4554-8403-118C8C1529D5}" type="datetimeFigureOut">
               <a:rPr lang="en-US" smtClean="0"/>
-              <a:t>4/29/2026</a:t>
+              <a:t>8/10/2026</a:t>
             </a:fld>
             <a:endParaRPr lang="en-US"/>
           </a:p>
@@ -5769,7 +5779,7 @@
           <a:p>
             <a:fld id="{8CF61943-3342-4554-8403-118C8C1529D5}" type="datetimeFigureOut">
               <a:rPr lang="en-US" smtClean="0"/>
-              <a:t>4/29/2026</a:t>
+              <a:t>8/10/2026</a:t>
             </a:fld>
             <a:endParaRPr lang="en-US"/>
           </a:p>
@@ -6165,290 +6175,6 @@
   <p:cSld>
     <p:spTree>
       <p:nvGrpSpPr>
-        <p:cNvPr id="1" name=""/>
-        <p:cNvGrpSpPr/>
-        <p:nvPr/>
-      </p:nvGrpSpPr>
-      <p:grpSpPr>
-        <a:xfrm>
-          <a:off x="0" y="0"/>
-          <a:ext cx="0" cy="0"/>
-          <a:chOff x="0" y="0"/>
-          <a:chExt cx="0" cy="0"/>
-        </a:xfrm>
-      </p:grpSpPr>
-      <p:sp>
-        <p:nvSpPr>
-          <p:cNvPr id="2" name="Text Placeholder 1">
-            <a:extLst>
-              <a:ext uri="{FF2B5EF4-FFF2-40B4-BE49-F238E27FC236}">
-                <a16:creationId xmlns:a16="http://schemas.microsoft.com/office/drawing/2014/main" id="{168CC41A-92DC-4526-9165-E4D3020A5F9A}"/>
-              </a:ext>
-            </a:extLst>
-          </p:cNvPr>
-          <p:cNvSpPr>
-            <a:spLocks noGrp="1"/>
-          </p:cNvSpPr>
-          <p:nvPr>
-            <p:ph type="body" sz="quarter" idx="10"/>
-          </p:nvPr>
-        </p:nvSpPr>
-        <p:spPr/>
-        <p:txBody>
-          <a:bodyPr/>
-          <a:lstStyle/>
-          <a:p>
-            <a:r>
-              <a:rPr lang="en-US" dirty="0"/>
-              <a:t>Auto-ISAC ACT Advanced Wireless Lab - 2026</a:t>
-            </a:r>
-          </a:p>
-        </p:txBody>
-      </p:sp>
-      <p:sp>
-        <p:nvSpPr>
-          <p:cNvPr id="4" name="Text Placeholder 3">
-            <a:extLst>
-              <a:ext uri="{FF2B5EF4-FFF2-40B4-BE49-F238E27FC236}">
-                <a16:creationId xmlns:a16="http://schemas.microsoft.com/office/drawing/2014/main" id="{37CF222F-449F-AEF7-61FD-D75CFCD9EC5D}"/>
-              </a:ext>
-            </a:extLst>
-          </p:cNvPr>
-          <p:cNvSpPr>
-            <a:spLocks noGrp="1"/>
-          </p:cNvSpPr>
-          <p:nvPr>
-            <p:ph type="body" sz="quarter" idx="12"/>
-          </p:nvPr>
-        </p:nvSpPr>
-        <p:spPr>
-          <a:xfrm>
-            <a:off x="270415" y="717259"/>
-            <a:ext cx="11658059" cy="5327941"/>
-          </a:xfrm>
-        </p:spPr>
-        <p:txBody>
-          <a:bodyPr>
-            <a:normAutofit fontScale="85000" lnSpcReduction="20000"/>
-          </a:bodyPr>
-          <a:lstStyle/>
-          <a:p>
-            <a:pPr marL="285750" indent="-285750">
-              <a:buFont typeface="Arial" panose="020B0604020202020204" pitchFamily="34" charset="0"/>
-              <a:buChar char="•"/>
-            </a:pPr>
-            <a:r>
-              <a:rPr lang="en-US" sz="1600" b="1" dirty="0"/>
-              <a:t>FCC ID</a:t>
-            </a:r>
-          </a:p>
-          <a:p>
-            <a:pPr marL="285750" indent="-285750">
-              <a:buFont typeface="Arial" panose="020B0604020202020204" pitchFamily="34" charset="0"/>
-              <a:buChar char="•"/>
-            </a:pPr>
-            <a:r>
-              <a:rPr lang="en-US" sz="1600" b="1" dirty="0"/>
-              <a:t>Bluetooth</a:t>
-            </a:r>
-          </a:p>
-          <a:p>
-            <a:pPr marL="971550" lvl="1" indent="-285750"/>
-            <a:r>
-              <a:rPr lang="en-US" sz="1400" dirty="0"/>
-              <a:t>Scanning</a:t>
-            </a:r>
-          </a:p>
-          <a:p>
-            <a:pPr marL="971550" lvl="1" indent="-285750"/>
-            <a:r>
-              <a:rPr lang="en-US" sz="1400" dirty="0"/>
-              <a:t>Enumerating</a:t>
-            </a:r>
-          </a:p>
-          <a:p>
-            <a:pPr marL="971550" lvl="1" indent="-285750"/>
-            <a:r>
-              <a:rPr lang="en-US" sz="1400" dirty="0"/>
-              <a:t>Identifying</a:t>
-            </a:r>
-          </a:p>
-          <a:p>
-            <a:pPr marL="971550" lvl="1" indent="-285750"/>
-            <a:r>
-              <a:rPr lang="en-US" sz="1400" dirty="0"/>
-              <a:t>Analyzing</a:t>
-            </a:r>
-          </a:p>
-          <a:p>
-            <a:pPr marL="971550" lvl="1" indent="-285750"/>
-            <a:r>
-              <a:rPr lang="en-US" sz="1400" dirty="0"/>
-              <a:t>Pairing</a:t>
-            </a:r>
-          </a:p>
-          <a:p>
-            <a:pPr marL="971550" lvl="1" indent="-285750"/>
-            <a:r>
-              <a:rPr lang="en-US" sz="1400" dirty="0"/>
-              <a:t>Data</a:t>
-            </a:r>
-          </a:p>
-          <a:p>
-            <a:pPr marL="285750" indent="-285750">
-              <a:buFont typeface="Arial" panose="020B0604020202020204" pitchFamily="34" charset="0"/>
-              <a:buChar char="•"/>
-            </a:pPr>
-            <a:r>
-              <a:rPr lang="en-US" sz="1600" b="1" dirty="0" err="1"/>
-              <a:t>WiFi</a:t>
-            </a:r>
-            <a:endParaRPr lang="en-US" sz="1600" b="1" dirty="0"/>
-          </a:p>
-          <a:p>
-            <a:pPr marL="971550" lvl="1" indent="-285750"/>
-            <a:r>
-              <a:rPr lang="en-US" sz="1400" dirty="0"/>
-              <a:t>Analyzer</a:t>
-            </a:r>
-          </a:p>
-          <a:p>
-            <a:pPr marL="971550" lvl="1" indent="-285750"/>
-            <a:r>
-              <a:rPr lang="en-US" sz="1400" dirty="0" err="1"/>
-              <a:t>WiFite</a:t>
-            </a:r>
-            <a:endParaRPr lang="en-US" sz="1400" dirty="0"/>
-          </a:p>
-          <a:p>
-            <a:pPr marL="971550" lvl="1" indent="-285750"/>
-            <a:r>
-              <a:rPr lang="en-US" sz="1400" dirty="0" err="1"/>
-              <a:t>HackISAC</a:t>
-            </a:r>
-            <a:endParaRPr lang="en-US" sz="1400" dirty="0"/>
-          </a:p>
-          <a:p>
-            <a:pPr marL="285750" indent="-285750">
-              <a:buFont typeface="Arial" panose="020B0604020202020204" pitchFamily="34" charset="0"/>
-              <a:buChar char="•"/>
-            </a:pPr>
-            <a:r>
-              <a:rPr lang="en-US" sz="1600" b="1" dirty="0"/>
-              <a:t>NFC</a:t>
-            </a:r>
-          </a:p>
-          <a:p>
-            <a:pPr marL="285750" indent="-285750">
-              <a:buFont typeface="Arial" panose="020B0604020202020204" pitchFamily="34" charset="0"/>
-              <a:buChar char="•"/>
-            </a:pPr>
-            <a:r>
-              <a:rPr lang="en-US" sz="1600" b="1" dirty="0"/>
-              <a:t>SDR</a:t>
-            </a:r>
-          </a:p>
-          <a:p>
-            <a:pPr marL="971550" lvl="1" indent="-285750"/>
-            <a:r>
-              <a:rPr lang="en-US" sz="1400" dirty="0"/>
-              <a:t>FM Radio</a:t>
-            </a:r>
-          </a:p>
-          <a:p>
-            <a:pPr marL="971550" lvl="1" indent="-285750"/>
-            <a:r>
-              <a:rPr lang="en-US" sz="1400" dirty="0" err="1"/>
-              <a:t>Keyfob</a:t>
-            </a:r>
-            <a:r>
-              <a:rPr lang="en-US" sz="1400" dirty="0"/>
-              <a:t> record</a:t>
-            </a:r>
-          </a:p>
-          <a:p>
-            <a:pPr marL="971550" lvl="1" indent="-285750"/>
-            <a:r>
-              <a:rPr lang="en-US" sz="1400" dirty="0" err="1"/>
-              <a:t>Keyfob</a:t>
-            </a:r>
-            <a:r>
-              <a:rPr lang="en-US" sz="1400" dirty="0"/>
-              <a:t> replay</a:t>
-            </a:r>
-          </a:p>
-          <a:p>
-            <a:pPr marL="971550" lvl="1" indent="-285750"/>
-            <a:r>
-              <a:rPr lang="en-US" sz="1400" dirty="0" err="1"/>
-              <a:t>Keyfob</a:t>
-            </a:r>
-            <a:r>
-              <a:rPr lang="en-US" sz="1400" dirty="0"/>
-              <a:t> decode</a:t>
-            </a:r>
-          </a:p>
-          <a:p>
-            <a:pPr marL="285750" indent="-285750">
-              <a:buFont typeface="Arial" panose="020B0604020202020204" pitchFamily="34" charset="0"/>
-              <a:buChar char="•"/>
-            </a:pPr>
-            <a:r>
-              <a:rPr lang="en-US" sz="1600" b="1" dirty="0"/>
-              <a:t>Cellular</a:t>
-            </a:r>
-          </a:p>
-          <a:p>
-            <a:pPr marL="285750" indent="-285750">
-              <a:buFont typeface="Arial" panose="020B0604020202020204" pitchFamily="34" charset="0"/>
-              <a:buChar char="•"/>
-            </a:pPr>
-            <a:r>
-              <a:rPr lang="en-US" sz="1600" b="1" dirty="0"/>
-              <a:t>GPS</a:t>
-            </a:r>
-          </a:p>
-          <a:p>
-            <a:pPr marL="285750" indent="-285750">
-              <a:buFont typeface="Arial" panose="020B0604020202020204" pitchFamily="34" charset="0"/>
-              <a:buChar char="•"/>
-            </a:pPr>
-            <a:r>
-              <a:rPr lang="en-US" sz="1600" b="1" dirty="0" err="1"/>
-              <a:t>Headunit</a:t>
-            </a:r>
-            <a:endParaRPr lang="en-US" sz="1600" b="1" dirty="0"/>
-          </a:p>
-          <a:p>
-            <a:pPr marL="285750" indent="-285750">
-              <a:buFont typeface="Arial" panose="020B0604020202020204" pitchFamily="34" charset="0"/>
-              <a:buChar char="•"/>
-            </a:pPr>
-            <a:r>
-              <a:rPr lang="en-US" sz="1600" b="1" dirty="0"/>
-              <a:t>RDS</a:t>
-            </a:r>
-          </a:p>
-        </p:txBody>
-      </p:sp>
-    </p:spTree>
-    <p:extLst>
-      <p:ext uri="{BB962C8B-B14F-4D97-AF65-F5344CB8AC3E}">
-        <p14:creationId xmlns:p14="http://schemas.microsoft.com/office/powerpoint/2010/main" val="1194985742"/>
-      </p:ext>
-    </p:extLst>
-  </p:cSld>
-  <p:clrMapOvr>
-    <a:masterClrMapping/>
-  </p:clrMapOvr>
-</p:sld>
-</file>
-
-<file path=ppt/slides/slide2.xml><?xml version="1.0" encoding="utf-8"?>
-<p:sld xmlns:a="http://schemas.openxmlformats.org/drawingml/2006/main" xmlns:r="http://schemas.openxmlformats.org/officeDocument/2006/relationships" xmlns:p="http://schemas.openxmlformats.org/presentationml/2006/main">
-  <p:cSld>
-    <p:spTree>
-      <p:nvGrpSpPr>
         <p:cNvPr id="1" name="">
           <a:extLst>
             <a:ext uri="{FF2B5EF4-FFF2-40B4-BE49-F238E27FC236}">
@@ -6673,6 +6399,30 @@
               </a:solidFill>
               <a:ea typeface="ＭＳ Ｐゴシック" pitchFamily="50" charset="-128"/>
             </a:endParaRPr>
+          </a:p>
+          <a:p>
+            <a:pPr lvl="0" fontAlgn="base">
+              <a:lnSpc>
+                <a:spcPct val="100000"/>
+              </a:lnSpc>
+              <a:spcBef>
+                <a:spcPct val="0"/>
+              </a:spcBef>
+              <a:spcAft>
+                <a:spcPct val="0"/>
+              </a:spcAft>
+              <a:buFont typeface="Wingdings" panose="05000000000000000000" pitchFamily="2" charset="2"/>
+              <a:buChar char="§"/>
+            </a:pPr>
+            <a:r>
+              <a:rPr lang="en-US" altLang="ja-JP" sz="2000" dirty="0">
+                <a:solidFill>
+                  <a:srgbClr val="000000"/>
+                </a:solidFill>
+                <a:ea typeface="ＭＳ Ｐゴシック" pitchFamily="50" charset="-128"/>
+              </a:rPr>
+              <a:t>Auto-ISAC PoC for Nissan</a:t>
+            </a:r>
           </a:p>
           <a:p>
             <a:pPr lvl="0" fontAlgn="base">
@@ -6964,7 +6714,686 @@
 </p:sld>
 </file>
 
+<file path=ppt/slides/slide2.xml><?xml version="1.0" encoding="utf-8"?>
+<p:sld xmlns:a="http://schemas.openxmlformats.org/drawingml/2006/main" xmlns:r="http://schemas.openxmlformats.org/officeDocument/2006/relationships" xmlns:p="http://schemas.openxmlformats.org/presentationml/2006/main">
+  <p:cSld>
+    <p:spTree>
+      <p:nvGrpSpPr>
+        <p:cNvPr id="1" name=""/>
+        <p:cNvGrpSpPr/>
+        <p:nvPr/>
+      </p:nvGrpSpPr>
+      <p:grpSpPr>
+        <a:xfrm>
+          <a:off x="0" y="0"/>
+          <a:ext cx="0" cy="0"/>
+          <a:chOff x="0" y="0"/>
+          <a:chExt cx="0" cy="0"/>
+        </a:xfrm>
+      </p:grpSpPr>
+      <p:sp>
+        <p:nvSpPr>
+          <p:cNvPr id="2" name="Text Placeholder 1">
+            <a:extLst>
+              <a:ext uri="{FF2B5EF4-FFF2-40B4-BE49-F238E27FC236}">
+                <a16:creationId xmlns:a16="http://schemas.microsoft.com/office/drawing/2014/main" id="{0AB79438-1929-B66C-5A54-EEE0BFBB59B8}"/>
+              </a:ext>
+            </a:extLst>
+          </p:cNvPr>
+          <p:cNvSpPr>
+            <a:spLocks noGrp="1"/>
+          </p:cNvSpPr>
+          <p:nvPr>
+            <p:ph type="body" sz="quarter" idx="10"/>
+          </p:nvPr>
+        </p:nvSpPr>
+        <p:spPr/>
+        <p:txBody>
+          <a:bodyPr/>
+          <a:lstStyle/>
+          <a:p>
+            <a:r>
+              <a:rPr lang="en-US" dirty="0"/>
+              <a:t>Virtual Box Setup</a:t>
+            </a:r>
+          </a:p>
+        </p:txBody>
+      </p:sp>
+      <p:sp>
+        <p:nvSpPr>
+          <p:cNvPr id="4" name="Text Placeholder 3">
+            <a:extLst>
+              <a:ext uri="{FF2B5EF4-FFF2-40B4-BE49-F238E27FC236}">
+                <a16:creationId xmlns:a16="http://schemas.microsoft.com/office/drawing/2014/main" id="{3E53296E-8822-77F5-4641-9716D98ADCC1}"/>
+              </a:ext>
+            </a:extLst>
+          </p:cNvPr>
+          <p:cNvSpPr>
+            <a:spLocks noGrp="1"/>
+          </p:cNvSpPr>
+          <p:nvPr>
+            <p:ph type="body" sz="quarter" idx="12"/>
+          </p:nvPr>
+        </p:nvSpPr>
+        <p:spPr>
+          <a:xfrm>
+            <a:off x="270415" y="685800"/>
+            <a:ext cx="11658059" cy="5359400"/>
+          </a:xfrm>
+        </p:spPr>
+        <p:txBody>
+          <a:bodyPr/>
+          <a:lstStyle/>
+          <a:p>
+            <a:r>
+              <a:rPr lang="en-US" dirty="0"/>
+              <a:t>VirtualBox is a general-purpose full virtualization software for x86_64 hardware (with version 7.1 additionally for macOS/Arm and with version 7.2 also for Windows/Arm), targeted at laptop, desktop, server and embedded use.</a:t>
+            </a:r>
+          </a:p>
+          <a:p>
+            <a:r>
+              <a:rPr lang="en-US" dirty="0"/>
+              <a:t>The provided laptop comes with VirtualBox setup with a Kali Linux VM and additional applications needed.</a:t>
+            </a:r>
+          </a:p>
+          <a:p>
+            <a:r>
+              <a:rPr lang="en-US" dirty="0"/>
+              <a:t>But if you want to DYI on your own laptop (Windows 10/11), here are some instructions to get started:</a:t>
+            </a:r>
+          </a:p>
+          <a:p>
+            <a:pPr marL="285750" indent="-285750">
+              <a:buFont typeface="Arial" panose="020B0604020202020204" pitchFamily="34" charset="0"/>
+              <a:buChar char="•"/>
+            </a:pPr>
+            <a:r>
+              <a:rPr lang="en-US" dirty="0"/>
+              <a:t>Download from here: </a:t>
+            </a:r>
+            <a:r>
+              <a:rPr lang="en-US" dirty="0">
+                <a:hlinkClick r:id="rId2"/>
+              </a:rPr>
+              <a:t>Downloads – Oracle VirtualBox</a:t>
+            </a:r>
+            <a:endParaRPr lang="en-US" dirty="0"/>
+          </a:p>
+          <a:p>
+            <a:pPr marL="285750" indent="-285750">
+              <a:buFont typeface="Arial" panose="020B0604020202020204" pitchFamily="34" charset="0"/>
+              <a:buChar char="•"/>
+            </a:pPr>
+            <a:r>
+              <a:rPr lang="en-US" dirty="0"/>
+              <a:t>Download both the Windows hosts platform package and the VirtualBox Extension Pack</a:t>
+            </a:r>
+          </a:p>
+          <a:p>
+            <a:pPr marL="971550" lvl="1" indent="-285750"/>
+            <a:r>
+              <a:rPr lang="en-US" sz="1600" dirty="0"/>
+              <a:t>Current version is 7.2.14</a:t>
+            </a:r>
+          </a:p>
+          <a:p>
+            <a:pPr marL="971550" lvl="1" indent="-285750"/>
+            <a:r>
+              <a:rPr lang="en-US" sz="1600" dirty="0">
+                <a:hlinkClick r:id="rId3"/>
+              </a:rPr>
+              <a:t>1.5. Installing Oracle VM VirtualBox and Extension Packs</a:t>
+            </a:r>
+            <a:endParaRPr lang="en-US" sz="1600" dirty="0"/>
+          </a:p>
+          <a:p>
+            <a:pPr marL="285750" indent="-285750">
+              <a:buFont typeface="Arial" panose="020B0604020202020204" pitchFamily="34" charset="0"/>
+              <a:buChar char="•"/>
+            </a:pPr>
+            <a:r>
+              <a:rPr lang="en-US" dirty="0"/>
+              <a:t>Install VirtualBox</a:t>
+            </a:r>
+          </a:p>
+          <a:p>
+            <a:pPr marL="971550" lvl="1" indent="-285750"/>
+            <a:r>
+              <a:rPr lang="en-US" sz="1600" dirty="0"/>
+              <a:t>Reboot</a:t>
+            </a:r>
+          </a:p>
+          <a:p>
+            <a:pPr marL="971550" lvl="1" indent="-285750"/>
+            <a:r>
+              <a:rPr lang="en-US" sz="1600" dirty="0"/>
+              <a:t>Run VirtualBox</a:t>
+            </a:r>
+          </a:p>
+          <a:p>
+            <a:pPr marL="971550" lvl="1" indent="-285750"/>
+            <a:r>
+              <a:rPr lang="en-US" sz="1600" dirty="0"/>
+              <a:t>The Extension Pack is installed from inside VirtualBox</a:t>
+            </a:r>
+          </a:p>
+          <a:p>
+            <a:pPr marL="1428750" lvl="2" indent="-285750"/>
+            <a:r>
+              <a:rPr lang="en-US" sz="1400" dirty="0">
+                <a:hlinkClick r:id="rId4"/>
+              </a:rPr>
+              <a:t>How to Install VirtualBox Extension Pack</a:t>
+            </a:r>
+            <a:endParaRPr lang="en-US" sz="1400" dirty="0"/>
+          </a:p>
+          <a:p>
+            <a:endParaRPr lang="en-US" dirty="0"/>
+          </a:p>
+        </p:txBody>
+      </p:sp>
+    </p:spTree>
+    <p:extLst>
+      <p:ext uri="{BB962C8B-B14F-4D97-AF65-F5344CB8AC3E}">
+        <p14:creationId xmlns:p14="http://schemas.microsoft.com/office/powerpoint/2010/main" val="1138735239"/>
+      </p:ext>
+    </p:extLst>
+  </p:cSld>
+  <p:clrMapOvr>
+    <a:masterClrMapping/>
+  </p:clrMapOvr>
+</p:sld>
+</file>
+
 <file path=ppt/slides/slide3.xml><?xml version="1.0" encoding="utf-8"?>
+<p:sld xmlns:a="http://schemas.openxmlformats.org/drawingml/2006/main" xmlns:r="http://schemas.openxmlformats.org/officeDocument/2006/relationships" xmlns:p="http://schemas.openxmlformats.org/presentationml/2006/main">
+  <p:cSld>
+    <p:spTree>
+      <p:nvGrpSpPr>
+        <p:cNvPr id="1" name=""/>
+        <p:cNvGrpSpPr/>
+        <p:nvPr/>
+      </p:nvGrpSpPr>
+      <p:grpSpPr>
+        <a:xfrm>
+          <a:off x="0" y="0"/>
+          <a:ext cx="0" cy="0"/>
+          <a:chOff x="0" y="0"/>
+          <a:chExt cx="0" cy="0"/>
+        </a:xfrm>
+      </p:grpSpPr>
+      <p:sp>
+        <p:nvSpPr>
+          <p:cNvPr id="2" name="Text Placeholder 1">
+            <a:extLst>
+              <a:ext uri="{FF2B5EF4-FFF2-40B4-BE49-F238E27FC236}">
+                <a16:creationId xmlns:a16="http://schemas.microsoft.com/office/drawing/2014/main" id="{B0A7F1C4-B3CB-5335-CD67-EDAD8D2A6390}"/>
+              </a:ext>
+            </a:extLst>
+          </p:cNvPr>
+          <p:cNvSpPr>
+            <a:spLocks noGrp="1"/>
+          </p:cNvSpPr>
+          <p:nvPr>
+            <p:ph type="body" sz="quarter" idx="10"/>
+          </p:nvPr>
+        </p:nvSpPr>
+        <p:spPr/>
+        <p:txBody>
+          <a:bodyPr/>
+          <a:lstStyle/>
+          <a:p>
+            <a:r>
+              <a:rPr lang="en-US" dirty="0"/>
+              <a:t>Kali Linux Setup</a:t>
+            </a:r>
+          </a:p>
+        </p:txBody>
+      </p:sp>
+      <p:sp>
+        <p:nvSpPr>
+          <p:cNvPr id="4" name="Text Placeholder 3">
+            <a:extLst>
+              <a:ext uri="{FF2B5EF4-FFF2-40B4-BE49-F238E27FC236}">
+                <a16:creationId xmlns:a16="http://schemas.microsoft.com/office/drawing/2014/main" id="{6861CE8A-4CFB-AD02-DB70-80AB233B185D}"/>
+              </a:ext>
+            </a:extLst>
+          </p:cNvPr>
+          <p:cNvSpPr>
+            <a:spLocks noGrp="1"/>
+          </p:cNvSpPr>
+          <p:nvPr>
+            <p:ph type="body" sz="quarter" idx="12"/>
+          </p:nvPr>
+        </p:nvSpPr>
+        <p:spPr>
+          <a:xfrm>
+            <a:off x="270415" y="640080"/>
+            <a:ext cx="11658059" cy="5405120"/>
+          </a:xfrm>
+        </p:spPr>
+        <p:txBody>
+          <a:bodyPr/>
+          <a:lstStyle/>
+          <a:p>
+            <a:r>
+              <a:rPr lang="en-US" dirty="0"/>
+              <a:t>Kali Linux is an open-source, Debian-based Linux distribution geared towards various information security tasks, such as Penetration Testing, Security Research, Computer Forensics and Reverse Engineering.</a:t>
+            </a:r>
+          </a:p>
+          <a:p>
+            <a:r>
+              <a:rPr lang="en-US" dirty="0"/>
+              <a:t>If you want to DYI on your own laptop, there are 2 ways to go about it:</a:t>
+            </a:r>
+          </a:p>
+          <a:p>
+            <a:pPr marL="285750" indent="-285750">
+              <a:buFont typeface="Arial" panose="020B0604020202020204" pitchFamily="34" charset="0"/>
+              <a:buChar char="•"/>
+            </a:pPr>
+            <a:r>
+              <a:rPr lang="en-US" dirty="0"/>
+              <a:t>Kali Linux VirtualBox VM</a:t>
+            </a:r>
+          </a:p>
+          <a:p>
+            <a:pPr marL="971550" lvl="1" indent="-285750"/>
+            <a:r>
+              <a:rPr lang="en-US" sz="1600" dirty="0">
+                <a:hlinkClick r:id="rId2"/>
+              </a:rPr>
+              <a:t>Get Kali | Kali Linux</a:t>
+            </a:r>
+            <a:r>
+              <a:rPr lang="en-US" sz="1600" dirty="0"/>
+              <a:t> and download the VirtualBox version</a:t>
+            </a:r>
+          </a:p>
+          <a:p>
+            <a:pPr marL="971550" lvl="1" indent="-285750"/>
+            <a:r>
+              <a:rPr lang="en-US" sz="1600" dirty="0"/>
+              <a:t>Add the VM and open the file from inside VirtualBox </a:t>
+            </a:r>
+          </a:p>
+          <a:p>
+            <a:pPr marL="971550" lvl="1" indent="-285750"/>
+            <a:r>
+              <a:rPr lang="en-US" sz="1600" dirty="0">
+                <a:hlinkClick r:id="rId3"/>
+              </a:rPr>
+              <a:t>How to Install Kali Linux in VirtualBox: Complete Setup Guide – </a:t>
+            </a:r>
+            <a:r>
+              <a:rPr lang="en-US" sz="1600" dirty="0" err="1">
+                <a:hlinkClick r:id="rId3"/>
+              </a:rPr>
+              <a:t>LinuxForDevices</a:t>
+            </a:r>
+            <a:endParaRPr lang="en-US" sz="1600" dirty="0"/>
+          </a:p>
+          <a:p>
+            <a:pPr marL="285750" indent="-285750">
+              <a:buFont typeface="Arial" panose="020B0604020202020204" pitchFamily="34" charset="0"/>
+              <a:buChar char="•"/>
+            </a:pPr>
+            <a:r>
+              <a:rPr lang="en-US" dirty="0"/>
+              <a:t>Bare metal Kali Linux</a:t>
+            </a:r>
+          </a:p>
+          <a:p>
+            <a:pPr marL="971550" lvl="1" indent="-285750"/>
+            <a:r>
+              <a:rPr lang="en-US" sz="1600" dirty="0">
+                <a:hlinkClick r:id="rId4"/>
+              </a:rPr>
+              <a:t>Get Kali | Kali Linux</a:t>
+            </a:r>
+            <a:r>
+              <a:rPr lang="en-US" sz="1600" dirty="0"/>
+              <a:t> and download the ISO image to put on a bootable USB thumb drive</a:t>
+            </a:r>
+          </a:p>
+          <a:p>
+            <a:pPr marL="971550" lvl="1" indent="-285750"/>
+            <a:r>
+              <a:rPr lang="en-US" sz="1600" dirty="0"/>
+              <a:t>This gets you a Kali Linux that boots up on your Laptop</a:t>
+            </a:r>
+          </a:p>
+          <a:p>
+            <a:pPr marL="971550" lvl="1" indent="-285750"/>
+            <a:r>
+              <a:rPr lang="en-US" sz="1600" dirty="0"/>
+              <a:t>However, you may wipe out existing Windows installation or create a dual boot.  Either way you must have space for it on your disk</a:t>
+            </a:r>
+          </a:p>
+          <a:p>
+            <a:pPr marL="971550" lvl="1" indent="-285750"/>
+            <a:r>
+              <a:rPr lang="en-US" sz="1600" dirty="0">
+                <a:hlinkClick r:id="rId5"/>
+              </a:rPr>
+              <a:t>Making a Kali Bootable USB Drive on Windows | Kali Linux Documentation</a:t>
+            </a:r>
+            <a:endParaRPr lang="en-US" sz="1600" dirty="0"/>
+          </a:p>
+          <a:p>
+            <a:pPr marL="971550" lvl="1" indent="-285750"/>
+            <a:endParaRPr lang="en-US" sz="1600" dirty="0"/>
+          </a:p>
+          <a:p>
+            <a:pPr marL="971550" lvl="1" indent="-285750"/>
+            <a:endParaRPr lang="en-US" sz="1600" dirty="0"/>
+          </a:p>
+          <a:p>
+            <a:pPr marL="285750" indent="-285750"/>
+            <a:endParaRPr lang="en-US" sz="1000" dirty="0"/>
+          </a:p>
+          <a:p>
+            <a:pPr marL="285750" indent="-285750"/>
+            <a:endParaRPr lang="en-US" sz="1000" dirty="0"/>
+          </a:p>
+          <a:p>
+            <a:endParaRPr lang="en-US" dirty="0"/>
+          </a:p>
+        </p:txBody>
+      </p:sp>
+    </p:spTree>
+    <p:extLst>
+      <p:ext uri="{BB962C8B-B14F-4D97-AF65-F5344CB8AC3E}">
+        <p14:creationId xmlns:p14="http://schemas.microsoft.com/office/powerpoint/2010/main" val="1104338654"/>
+      </p:ext>
+    </p:extLst>
+  </p:cSld>
+  <p:clrMapOvr>
+    <a:masterClrMapping/>
+  </p:clrMapOvr>
+</p:sld>
+</file>
+
+<file path=ppt/slides/slide4.xml><?xml version="1.0" encoding="utf-8"?>
+<p:sld xmlns:a="http://schemas.openxmlformats.org/drawingml/2006/main" xmlns:r="http://schemas.openxmlformats.org/officeDocument/2006/relationships" xmlns:p="http://schemas.openxmlformats.org/presentationml/2006/main">
+  <p:cSld>
+    <p:spTree>
+      <p:nvGrpSpPr>
+        <p:cNvPr id="1" name=""/>
+        <p:cNvGrpSpPr/>
+        <p:nvPr/>
+      </p:nvGrpSpPr>
+      <p:grpSpPr>
+        <a:xfrm>
+          <a:off x="0" y="0"/>
+          <a:ext cx="0" cy="0"/>
+          <a:chOff x="0" y="0"/>
+          <a:chExt cx="0" cy="0"/>
+        </a:xfrm>
+      </p:grpSpPr>
+      <p:sp>
+        <p:nvSpPr>
+          <p:cNvPr id="2" name="Text Placeholder 1">
+            <a:extLst>
+              <a:ext uri="{FF2B5EF4-FFF2-40B4-BE49-F238E27FC236}">
+                <a16:creationId xmlns:a16="http://schemas.microsoft.com/office/drawing/2014/main" id="{168CC41A-92DC-4526-9165-E4D3020A5F9A}"/>
+              </a:ext>
+            </a:extLst>
+          </p:cNvPr>
+          <p:cNvSpPr>
+            <a:spLocks noGrp="1"/>
+          </p:cNvSpPr>
+          <p:nvPr>
+            <p:ph type="body" sz="quarter" idx="10"/>
+          </p:nvPr>
+        </p:nvSpPr>
+        <p:spPr/>
+        <p:txBody>
+          <a:bodyPr/>
+          <a:lstStyle/>
+          <a:p>
+            <a:r>
+              <a:rPr lang="en-US" dirty="0"/>
+              <a:t>Auto-ISAC ACT Advanced Wireless Lab - 2026</a:t>
+            </a:r>
+          </a:p>
+        </p:txBody>
+      </p:sp>
+      <p:sp>
+        <p:nvSpPr>
+          <p:cNvPr id="4" name="Text Placeholder 3">
+            <a:extLst>
+              <a:ext uri="{FF2B5EF4-FFF2-40B4-BE49-F238E27FC236}">
+                <a16:creationId xmlns:a16="http://schemas.microsoft.com/office/drawing/2014/main" id="{37CF222F-449F-AEF7-61FD-D75CFCD9EC5D}"/>
+              </a:ext>
+            </a:extLst>
+          </p:cNvPr>
+          <p:cNvSpPr>
+            <a:spLocks noGrp="1"/>
+          </p:cNvSpPr>
+          <p:nvPr>
+            <p:ph type="body" sz="quarter" idx="12"/>
+          </p:nvPr>
+        </p:nvSpPr>
+        <p:spPr>
+          <a:xfrm>
+            <a:off x="270415" y="717259"/>
+            <a:ext cx="11658059" cy="5327941"/>
+          </a:xfrm>
+        </p:spPr>
+        <p:txBody>
+          <a:bodyPr>
+            <a:normAutofit fontScale="92500" lnSpcReduction="20000"/>
+          </a:bodyPr>
+          <a:lstStyle/>
+          <a:p>
+            <a:pPr marL="285750" indent="-285750">
+              <a:buFont typeface="Arial" panose="020B0604020202020204" pitchFamily="34" charset="0"/>
+              <a:buChar char="•"/>
+            </a:pPr>
+            <a:r>
+              <a:rPr lang="en-US" sz="1600" b="1" dirty="0"/>
+              <a:t>FCC ID</a:t>
+            </a:r>
+          </a:p>
+          <a:p>
+            <a:pPr marL="971550" lvl="1" indent="-285750"/>
+            <a:r>
+              <a:rPr lang="en-US" sz="1300" dirty="0"/>
+              <a:t>Lookup</a:t>
+            </a:r>
+          </a:p>
+          <a:p>
+            <a:pPr marL="285750" indent="-285750">
+              <a:buFont typeface="Arial" panose="020B0604020202020204" pitchFamily="34" charset="0"/>
+              <a:buChar char="•"/>
+            </a:pPr>
+            <a:r>
+              <a:rPr lang="en-US" sz="1600" b="1" dirty="0"/>
+              <a:t>Bluetooth</a:t>
+            </a:r>
+          </a:p>
+          <a:p>
+            <a:pPr marL="971550" lvl="1" indent="-285750"/>
+            <a:r>
+              <a:rPr lang="en-US" sz="1400" dirty="0"/>
+              <a:t>Scanning</a:t>
+            </a:r>
+          </a:p>
+          <a:p>
+            <a:pPr marL="971550" lvl="1" indent="-285750"/>
+            <a:r>
+              <a:rPr lang="en-US" sz="1400" dirty="0"/>
+              <a:t>Enumerating</a:t>
+            </a:r>
+          </a:p>
+          <a:p>
+            <a:pPr marL="971550" lvl="1" indent="-285750"/>
+            <a:r>
+              <a:rPr lang="en-US" sz="1400" dirty="0"/>
+              <a:t>Identifying</a:t>
+            </a:r>
+          </a:p>
+          <a:p>
+            <a:pPr marL="971550" lvl="1" indent="-285750"/>
+            <a:r>
+              <a:rPr lang="en-US" sz="1400" dirty="0"/>
+              <a:t>Analyzing</a:t>
+            </a:r>
+          </a:p>
+          <a:p>
+            <a:pPr marL="971550" lvl="1" indent="-285750"/>
+            <a:r>
+              <a:rPr lang="en-US" sz="1400" dirty="0"/>
+              <a:t>Pairing</a:t>
+            </a:r>
+          </a:p>
+          <a:p>
+            <a:pPr marL="971550" lvl="1" indent="-285750"/>
+            <a:r>
+              <a:rPr lang="en-US" sz="1400" dirty="0"/>
+              <a:t>Data</a:t>
+            </a:r>
+          </a:p>
+          <a:p>
+            <a:pPr marL="285750" indent="-285750">
+              <a:buFont typeface="Arial" panose="020B0604020202020204" pitchFamily="34" charset="0"/>
+              <a:buChar char="•"/>
+            </a:pPr>
+            <a:r>
+              <a:rPr lang="en-US" sz="1600" b="1" dirty="0" err="1"/>
+              <a:t>WiFi</a:t>
+            </a:r>
+            <a:endParaRPr lang="en-US" sz="1600" b="1" dirty="0"/>
+          </a:p>
+          <a:p>
+            <a:pPr marL="971550" lvl="1" indent="-285750"/>
+            <a:r>
+              <a:rPr lang="en-US" sz="1400" dirty="0"/>
+              <a:t>Analyzer</a:t>
+            </a:r>
+          </a:p>
+          <a:p>
+            <a:pPr marL="971550" lvl="1" indent="-285750"/>
+            <a:r>
+              <a:rPr lang="en-US" sz="1400" dirty="0" err="1"/>
+              <a:t>WiFite</a:t>
+            </a:r>
+            <a:endParaRPr lang="en-US" sz="1400" dirty="0"/>
+          </a:p>
+          <a:p>
+            <a:pPr marL="971550" lvl="1" indent="-285750"/>
+            <a:r>
+              <a:rPr lang="en-US" sz="1400" dirty="0" err="1"/>
+              <a:t>HackISAC</a:t>
+            </a:r>
+            <a:endParaRPr lang="en-US" sz="1400" dirty="0"/>
+          </a:p>
+          <a:p>
+            <a:pPr marL="285750" indent="-285750">
+              <a:buFont typeface="Arial" panose="020B0604020202020204" pitchFamily="34" charset="0"/>
+              <a:buChar char="•"/>
+            </a:pPr>
+            <a:r>
+              <a:rPr lang="en-US" sz="1600" b="1" dirty="0"/>
+              <a:t>SDR</a:t>
+            </a:r>
+          </a:p>
+          <a:p>
+            <a:pPr marL="971550" lvl="1" indent="-285750"/>
+            <a:r>
+              <a:rPr lang="en-US" sz="1400" dirty="0"/>
+              <a:t>FM Radio</a:t>
+            </a:r>
+          </a:p>
+          <a:p>
+            <a:pPr marL="971550" lvl="1" indent="-285750"/>
+            <a:r>
+              <a:rPr lang="en-US" sz="1400" dirty="0" err="1"/>
+              <a:t>Keyfob</a:t>
+            </a:r>
+            <a:r>
+              <a:rPr lang="en-US" sz="1400" dirty="0"/>
+              <a:t> record</a:t>
+            </a:r>
+          </a:p>
+          <a:p>
+            <a:pPr marL="971550" lvl="1" indent="-285750"/>
+            <a:r>
+              <a:rPr lang="en-US" sz="1400" dirty="0" err="1"/>
+              <a:t>Keyfob</a:t>
+            </a:r>
+            <a:r>
+              <a:rPr lang="en-US" sz="1400" dirty="0"/>
+              <a:t> replay</a:t>
+            </a:r>
+          </a:p>
+          <a:p>
+            <a:pPr marL="971550" lvl="1" indent="-285750"/>
+            <a:r>
+              <a:rPr lang="en-US" sz="1400" dirty="0" err="1"/>
+              <a:t>Keyfob</a:t>
+            </a:r>
+            <a:r>
+              <a:rPr lang="en-US" sz="1400" dirty="0"/>
+              <a:t> decode</a:t>
+            </a:r>
+          </a:p>
+          <a:p>
+            <a:pPr marL="285750" indent="-285750">
+              <a:buFont typeface="Arial" panose="020B0604020202020204" pitchFamily="34" charset="0"/>
+              <a:buChar char="•"/>
+            </a:pPr>
+            <a:r>
+              <a:rPr lang="en-US" sz="1600" b="1" dirty="0"/>
+              <a:t>GPS</a:t>
+            </a:r>
+          </a:p>
+          <a:p>
+            <a:pPr marL="971550" lvl="1" indent="-285750"/>
+            <a:r>
+              <a:rPr lang="en-US" sz="1400" dirty="0"/>
+              <a:t>Viewing</a:t>
+            </a:r>
+            <a:endParaRPr lang="en-US" sz="800" dirty="0"/>
+          </a:p>
+          <a:p>
+            <a:pPr marL="285750" indent="-285750">
+              <a:buFont typeface="Arial" panose="020B0604020202020204" pitchFamily="34" charset="0"/>
+              <a:buChar char="•"/>
+            </a:pPr>
+            <a:r>
+              <a:rPr lang="en-US" sz="1600" b="1" dirty="0"/>
+              <a:t>V2X</a:t>
+            </a:r>
+          </a:p>
+          <a:p>
+            <a:pPr marL="971550" lvl="1" indent="-285750"/>
+            <a:r>
+              <a:rPr lang="en-US" sz="1300" dirty="0"/>
+              <a:t>Overview</a:t>
+            </a:r>
+          </a:p>
+          <a:p>
+            <a:pPr marL="285750" indent="-285750"/>
+            <a:endParaRPr lang="en-US" sz="800" dirty="0"/>
+          </a:p>
+        </p:txBody>
+      </p:sp>
+    </p:spTree>
+    <p:extLst>
+      <p:ext uri="{BB962C8B-B14F-4D97-AF65-F5344CB8AC3E}">
+        <p14:creationId xmlns:p14="http://schemas.microsoft.com/office/powerpoint/2010/main" val="1194985742"/>
+      </p:ext>
+    </p:extLst>
+  </p:cSld>
+  <p:clrMapOvr>
+    <a:masterClrMapping/>
+  </p:clrMapOvr>
+</p:sld>
+</file>
+
+<file path=ppt/slides/slide5.xml><?xml version="1.0" encoding="utf-8"?>
 <p:sld xmlns:a="http://schemas.openxmlformats.org/drawingml/2006/main" xmlns:r="http://schemas.openxmlformats.org/officeDocument/2006/relationships" xmlns:p="http://schemas.openxmlformats.org/presentationml/2006/main" showMasterSp="0">
   <p:cSld>
     <p:spTree>
@@ -7486,7 +7915,7 @@
                   <a:spcPts val="2193"/>
                 </a:lnSpc>
               </a:pPr>
-              <a:t>3</a:t>
+              <a:t>5</a:t>
             </a:fld>
             <a:endParaRPr kern="0" spc="-33" dirty="0"/>
           </a:p>
@@ -7503,7 +7932,7 @@
 </p:sld>
 </file>
 
-<file path=ppt/slides/slide4.xml><?xml version="1.0" encoding="utf-8"?>
+<file path=ppt/slides/slide6.xml><?xml version="1.0" encoding="utf-8"?>
 <p:sld xmlns:a="http://schemas.openxmlformats.org/drawingml/2006/main" xmlns:r="http://schemas.openxmlformats.org/officeDocument/2006/relationships" xmlns:p="http://schemas.openxmlformats.org/presentationml/2006/main" showMasterSp="0">
   <p:cSld>
     <p:spTree>
@@ -8352,7 +8781,7 @@
                   <a:spcPts val="2193"/>
                 </a:lnSpc>
               </a:pPr>
-              <a:t>4</a:t>
+              <a:t>6</a:t>
             </a:fld>
             <a:endParaRPr kern="0" spc="-33" dirty="0"/>
           </a:p>
@@ -8470,7 +8899,7 @@
 </p:sld>
 </file>
 
-<file path=ppt/slides/slide5.xml><?xml version="1.0" encoding="utf-8"?>
+<file path=ppt/slides/slide7.xml><?xml version="1.0" encoding="utf-8"?>
 <p:sld xmlns:a="http://schemas.openxmlformats.org/drawingml/2006/main" xmlns:r="http://schemas.openxmlformats.org/officeDocument/2006/relationships" xmlns:p="http://schemas.openxmlformats.org/presentationml/2006/main" showMasterSp="0">
   <p:cSld>
     <p:spTree>
@@ -9827,15 +10256,6 @@
 </file>
 
 <file path=customXml/item1.xml><?xml version="1.0" encoding="utf-8"?>
-<?mso-contentType ?>
-<FormTemplates xmlns="http://schemas.microsoft.com/sharepoint/v3/contenttype/forms">
-  <Display>DocumentLibraryForm</Display>
-  <Edit>DocumentLibraryForm</Edit>
-  <New>DocumentLibraryForm</New>
-</FormTemplates>
-</file>
-
-<file path=customXml/item2.xml><?xml version="1.0" encoding="utf-8"?>
 <ct:contentTypeSchema xmlns:ct="http://schemas.microsoft.com/office/2006/metadata/contentType" xmlns:ma="http://schemas.microsoft.com/office/2006/metadata/properties/metaAttributes" ct:_="" ma:_="" ma:contentTypeName="Document" ma:contentTypeID="0x01010067B86F8708159745A0B6896184DE9576" ma:contentTypeVersion="19" ma:contentTypeDescription="Create a new document." ma:contentTypeScope="" ma:versionID="493bf26d373952ea1ae3b9e24cd19b33">
   <xsd:schema xmlns:xsd="http://www.w3.org/2001/XMLSchema" xmlns:xs="http://www.w3.org/2001/XMLSchema" xmlns:p="http://schemas.microsoft.com/office/2006/metadata/properties" xmlns:ns2="c7a77415-c4a3-4262-8430-671f3e8707b6" xmlns:ns3="69a7259e-7a2c-42d5-bc84-25eccf0dce8b" targetNamespace="http://schemas.microsoft.com/office/2006/metadata/properties" ma:root="true" ma:fieldsID="69c00e31f84d56e19bb090b7ea67ab52" ns2:_="" ns3:_="">
     <xsd:import namespace="c7a77415-c4a3-4262-8430-671f3e8707b6"/>
@@ -10121,23 +10541,16 @@
 </ct:contentTypeSchema>
 </file>
 
-<file path=customXml/item3.xml><?xml version="1.0" encoding="utf-8"?>
-<p:properties xmlns:p="http://schemas.microsoft.com/office/2006/metadata/properties" xmlns:xsi="http://www.w3.org/2001/XMLSchema-instance" xmlns:pc="http://schemas.microsoft.com/office/infopath/2007/PartnerControls">
-  <documentManagement>
-    <_dlc_DocId xmlns="c7a77415-c4a3-4262-8430-671f3e8707b6">7J4PPY27XH2W-901365475-257158</_dlc_DocId>
-    <_dlc_DocIdUrl xmlns="c7a77415-c4a3-4262-8430-671f3e8707b6">
-      <Url>https://automotivei.sharepoint.com/sites/PMO/_layouts/15/DocIdRedir.aspx?ID=7J4PPY27XH2W-901365475-257158</Url>
-      <Description>7J4PPY27XH2W-901365475-257158</Description>
-    </_dlc_DocIdUrl>
-    <TaxCatchAll xmlns="c7a77415-c4a3-4262-8430-671f3e8707b6" xsi:nil="true"/>
-    <lcf76f155ced4ddcb4097134ff3c332f xmlns="69a7259e-7a2c-42d5-bc84-25eccf0dce8b">
-      <Terms xmlns="http://schemas.microsoft.com/office/infopath/2007/PartnerControls"/>
-    </lcf76f155ced4ddcb4097134ff3c332f>
-  </documentManagement>
-</p:properties>
+<file path=customXml/item2.xml><?xml version="1.0" encoding="utf-8"?>
+<?mso-contentType ?>
+<FormTemplates xmlns="http://schemas.microsoft.com/sharepoint/v3/contenttype/forms">
+  <Display>DocumentLibraryForm</Display>
+  <Edit>DocumentLibraryForm</Edit>
+  <New>DocumentLibraryForm</New>
+</FormTemplates>
 </file>
 
-<file path=customXml/item4.xml><?xml version="1.0" encoding="utf-8"?>
+<file path=customXml/item3.xml><?xml version="1.0" encoding="utf-8"?>
 <?mso-contentType ?>
 <spe:Receivers xmlns:spe="http://schemas.microsoft.com/sharepoint/events">
   <Receiver>
@@ -10187,15 +10600,23 @@
 </spe:Receivers>
 </file>
 
-<file path=customXml/itemProps1.xml><?xml version="1.0" encoding="utf-8"?>
-<ds:datastoreItem xmlns:ds="http://schemas.openxmlformats.org/officeDocument/2006/customXml" ds:itemID="{84EE72F3-C956-4A5B-833F-E761B5D8ACD8}">
-  <ds:schemaRefs>
-    <ds:schemaRef ds:uri="http://schemas.microsoft.com/sharepoint/v3/contenttype/forms"/>
-  </ds:schemaRefs>
-</ds:datastoreItem>
+<file path=customXml/item4.xml><?xml version="1.0" encoding="utf-8"?>
+<p:properties xmlns:p="http://schemas.microsoft.com/office/2006/metadata/properties" xmlns:xsi="http://www.w3.org/2001/XMLSchema-instance" xmlns:pc="http://schemas.microsoft.com/office/infopath/2007/PartnerControls">
+  <documentManagement>
+    <_dlc_DocId xmlns="c7a77415-c4a3-4262-8430-671f3e8707b6">7J4PPY27XH2W-901365475-257158</_dlc_DocId>
+    <_dlc_DocIdUrl xmlns="c7a77415-c4a3-4262-8430-671f3e8707b6">
+      <Url>https://automotivei.sharepoint.com/sites/PMO/_layouts/15/DocIdRedir.aspx?ID=7J4PPY27XH2W-901365475-257158</Url>
+      <Description>7J4PPY27XH2W-901365475-257158</Description>
+    </_dlc_DocIdUrl>
+    <TaxCatchAll xmlns="c7a77415-c4a3-4262-8430-671f3e8707b6" xsi:nil="true"/>
+    <lcf76f155ced4ddcb4097134ff3c332f xmlns="69a7259e-7a2c-42d5-bc84-25eccf0dce8b">
+      <Terms xmlns="http://schemas.microsoft.com/office/infopath/2007/PartnerControls"/>
+    </lcf76f155ced4ddcb4097134ff3c332f>
+  </documentManagement>
+</p:properties>
 </file>
 
-<file path=customXml/itemProps2.xml><?xml version="1.0" encoding="utf-8"?>
+<file path=customXml/itemProps1.xml><?xml version="1.0" encoding="utf-8"?>
 <ds:datastoreItem xmlns:ds="http://schemas.openxmlformats.org/officeDocument/2006/customXml" ds:itemID="{8FEF19B7-7529-453B-A7D5-A8465340F17A}">
   <ds:schemaRefs>
     <ds:schemaRef ds:uri="http://schemas.microsoft.com/office/2006/metadata/contentType"/>
@@ -10214,7 +10635,23 @@
 </ds:datastoreItem>
 </file>
 
+<file path=customXml/itemProps2.xml><?xml version="1.0" encoding="utf-8"?>
+<ds:datastoreItem xmlns:ds="http://schemas.openxmlformats.org/officeDocument/2006/customXml" ds:itemID="{84EE72F3-C956-4A5B-833F-E761B5D8ACD8}">
+  <ds:schemaRefs>
+    <ds:schemaRef ds:uri="http://schemas.microsoft.com/sharepoint/v3/contenttype/forms"/>
+  </ds:schemaRefs>
+</ds:datastoreItem>
+</file>
+
 <file path=customXml/itemProps3.xml><?xml version="1.0" encoding="utf-8"?>
+<ds:datastoreItem xmlns:ds="http://schemas.openxmlformats.org/officeDocument/2006/customXml" ds:itemID="{54C592EF-85C1-482B-896B-DED434B6FCCC}">
+  <ds:schemaRefs>
+    <ds:schemaRef ds:uri="http://schemas.microsoft.com/sharepoint/events"/>
+  </ds:schemaRefs>
+</ds:datastoreItem>
+</file>
+
+<file path=customXml/itemProps4.xml><?xml version="1.0" encoding="utf-8"?>
 <ds:datastoreItem xmlns:ds="http://schemas.openxmlformats.org/officeDocument/2006/customXml" ds:itemID="{E71A463F-9F4B-47AC-91AA-3962FD8F3CE5}">
   <ds:schemaRefs>
     <ds:schemaRef ds:uri="http://schemas.microsoft.com/office/2006/metadata/properties"/>
@@ -10223,12 +10660,4 @@
     <ds:schemaRef ds:uri="69a7259e-7a2c-42d5-bc84-25eccf0dce8b"/>
   </ds:schemaRefs>
 </ds:datastoreItem>
-</file>
-
-<file path=customXml/itemProps4.xml><?xml version="1.0" encoding="utf-8"?>
-<ds:datastoreItem xmlns:ds="http://schemas.openxmlformats.org/officeDocument/2006/customXml" ds:itemID="{54C592EF-85C1-482B-896B-DED434B6FCCC}">
-  <ds:schemaRefs>
-    <ds:schemaRef ds:uri="http://schemas.microsoft.com/sharepoint/events"/>
-  </ds:schemaRefs>
-</ds:datastoreItem>
 </file>
</xml_diff>

<commit_message>
Split intro from setup
</commit_message>
<xml_diff>
--- a/ACT AdvancedWireless 2026 - Setup.pptx
+++ b/ACT AdvancedWireless 2026 - Setup.pptx
@@ -5,21 +5,16 @@
     <p:sldMasterId id="2147483702" r:id="rId5"/>
   </p:sldMasterIdLst>
   <p:notesMasterIdLst>
-    <p:notesMasterId r:id="rId13"/>
+    <p:notesMasterId r:id="rId8"/>
   </p:notesMasterIdLst>
   <p:sldIdLst>
-    <p:sldId id="506" r:id="rId6"/>
-    <p:sldId id="508" r:id="rId7"/>
-    <p:sldId id="509" r:id="rId8"/>
-    <p:sldId id="507" r:id="rId9"/>
-    <p:sldId id="312" r:id="rId10"/>
-    <p:sldId id="310" r:id="rId11"/>
-    <p:sldId id="311" r:id="rId12"/>
+    <p:sldId id="508" r:id="rId6"/>
+    <p:sldId id="509" r:id="rId7"/>
   </p:sldIdLst>
   <p:sldSz cx="12192000" cy="6858000"/>
   <p:notesSz cx="6858000" cy="9144000"/>
   <p:custDataLst>
-    <p:tags r:id="rId14"/>
+    <p:tags r:id="rId9"/>
   </p:custDataLst>
   <p:defaultTextStyle>
     <a:defPPr>
@@ -119,11 +114,6 @@
   <p:extLst>
     <p:ext uri="{521415D9-36F7-43E2-AB2F-B90AF26B5E84}">
       <p14:sectionLst xmlns:p14="http://schemas.microsoft.com/office/powerpoint/2010/main">
-        <p14:section name="Setup" id="{40EEF03E-46C1-4B91-8015-EA960149133A}">
-          <p14:sldIdLst>
-            <p14:sldId id="506"/>
-          </p14:sldIdLst>
-        </p14:section>
         <p14:section name="Virtual Box" id="{CAC26D38-A0B5-405B-8045-57259533A223}">
           <p14:sldIdLst>
             <p14:sldId id="508"/>
@@ -132,18 +122,6 @@
         <p14:section name="Kali Linux" id="{AF6FF401-F398-49CD-982E-520170691C75}">
           <p14:sldIdLst>
             <p14:sldId id="509"/>
-          </p14:sldIdLst>
-        </p14:section>
-        <p14:section name="Syllabus" id="{A31229EC-853B-4205-8E31-6B44F371A12E}">
-          <p14:sldIdLst>
-            <p14:sldId id="507"/>
-          </p14:sldIdLst>
-        </p14:section>
-        <p14:section name="FCC ID" id="{996098ED-F625-41E8-8BD8-06E6CC46322C}">
-          <p14:sldIdLst>
-            <p14:sldId id="312"/>
-            <p14:sldId id="310"/>
-            <p14:sldId id="311"/>
           </p14:sldIdLst>
         </p14:section>
       </p14:sectionLst>
@@ -5056,7 +5034,7 @@
           <a:p>
             <a:fld id="{2FC2648E-2733-4EC8-BEDA-1577DE2D3D01}" type="datetimeFigureOut">
               <a:rPr lang="en-US" smtClean="0"/>
-              <a:t>8/10/2026</a:t>
+              <a:t>9/4/2026</a:t>
             </a:fld>
             <a:endParaRPr lang="en-US"/>
           </a:p>
@@ -5363,7 +5341,7 @@
           <a:p>
             <a:fld id="{8CF61943-3342-4554-8403-118C8C1529D5}" type="datetimeFigureOut">
               <a:rPr lang="en-US" smtClean="0"/>
-              <a:t>8/10/2026</a:t>
+              <a:t>9/4/2026</a:t>
             </a:fld>
             <a:endParaRPr lang="en-US"/>
           </a:p>
@@ -5779,7 +5757,7 @@
           <a:p>
             <a:fld id="{8CF61943-3342-4554-8403-118C8C1529D5}" type="datetimeFigureOut">
               <a:rPr lang="en-US" smtClean="0"/>
-              <a:t>8/10/2026</a:t>
+              <a:t>9/4/2026</a:t>
             </a:fld>
             <a:endParaRPr lang="en-US"/>
           </a:p>
@@ -6175,550 +6153,6 @@
   <p:cSld>
     <p:spTree>
       <p:nvGrpSpPr>
-        <p:cNvPr id="1" name="">
-          <a:extLst>
-            <a:ext uri="{FF2B5EF4-FFF2-40B4-BE49-F238E27FC236}">
-              <a16:creationId xmlns:a16="http://schemas.microsoft.com/office/drawing/2014/main" id="{99F95790-9782-F041-9855-3EA712D1272D}"/>
-            </a:ext>
-          </a:extLst>
-        </p:cNvPr>
-        <p:cNvGrpSpPr/>
-        <p:nvPr/>
-      </p:nvGrpSpPr>
-      <p:grpSpPr>
-        <a:xfrm>
-          <a:off x="0" y="0"/>
-          <a:ext cx="0" cy="0"/>
-          <a:chOff x="0" y="0"/>
-          <a:chExt cx="0" cy="0"/>
-        </a:xfrm>
-      </p:grpSpPr>
-      <p:sp>
-        <p:nvSpPr>
-          <p:cNvPr id="3" name="テキスト プレースホルダー 2">
-            <a:extLst>
-              <a:ext uri="{FF2B5EF4-FFF2-40B4-BE49-F238E27FC236}">
-                <a16:creationId xmlns:a16="http://schemas.microsoft.com/office/drawing/2014/main" id="{A6208E19-D911-EE2C-E87C-EC7983F2A0D9}"/>
-              </a:ext>
-            </a:extLst>
-          </p:cNvPr>
-          <p:cNvSpPr>
-            <a:spLocks noGrp="1"/>
-          </p:cNvSpPr>
-          <p:nvPr>
-            <p:ph type="body" sz="quarter" idx="10"/>
-          </p:nvPr>
-        </p:nvSpPr>
-        <p:spPr>
-          <a:xfrm>
-            <a:off x="263525" y="208032"/>
-            <a:ext cx="11412538" cy="563524"/>
-          </a:xfrm>
-        </p:spPr>
-        <p:txBody>
-          <a:bodyPr/>
-          <a:lstStyle/>
-          <a:p>
-            <a:r>
-              <a:rPr lang="en-US" altLang="ja-JP" kern="0" dirty="0">
-                <a:solidFill>
-                  <a:srgbClr val="000000"/>
-                </a:solidFill>
-                <a:ea typeface="ＭＳ Ｐゴシック"/>
-                <a:cs typeface="+mj-cs"/>
-              </a:rPr>
-              <a:t>Who am I?</a:t>
-            </a:r>
-            <a:endParaRPr kumimoji="1" lang="ja-JP" altLang="en-US" dirty="0"/>
-          </a:p>
-        </p:txBody>
-      </p:sp>
-      <p:sp>
-        <p:nvSpPr>
-          <p:cNvPr id="4" name="テキスト プレースホルダー 3">
-            <a:extLst>
-              <a:ext uri="{FF2B5EF4-FFF2-40B4-BE49-F238E27FC236}">
-                <a16:creationId xmlns:a16="http://schemas.microsoft.com/office/drawing/2014/main" id="{85DF450F-0F29-BDCA-0DD0-45BDDAFFE97F}"/>
-              </a:ext>
-            </a:extLst>
-          </p:cNvPr>
-          <p:cNvSpPr>
-            <a:spLocks noGrp="1"/>
-          </p:cNvSpPr>
-          <p:nvPr>
-            <p:ph type="body" sz="quarter" idx="11"/>
-          </p:nvPr>
-        </p:nvSpPr>
-        <p:spPr>
-          <a:xfrm>
-            <a:off x="263525" y="877636"/>
-            <a:ext cx="11160126" cy="5618167"/>
-          </a:xfrm>
-        </p:spPr>
-        <p:txBody>
-          <a:bodyPr/>
-          <a:lstStyle/>
-          <a:p>
-            <a:pPr lvl="0" fontAlgn="base">
-              <a:lnSpc>
-                <a:spcPct val="100000"/>
-              </a:lnSpc>
-              <a:spcBef>
-                <a:spcPct val="0"/>
-              </a:spcBef>
-              <a:spcAft>
-                <a:spcPct val="0"/>
-              </a:spcAft>
-              <a:buFont typeface="Wingdings" panose="05000000000000000000" pitchFamily="2" charset="2"/>
-              <a:buChar char="§"/>
-            </a:pPr>
-            <a:r>
-              <a:rPr lang="en-US" altLang="ja-JP" sz="2000" dirty="0">
-                <a:solidFill>
-                  <a:srgbClr val="000000"/>
-                </a:solidFill>
-                <a:ea typeface="ＭＳ Ｐゴシック" pitchFamily="50" charset="-128"/>
-              </a:rPr>
-              <a:t>Neal Probert </a:t>
-            </a:r>
-            <a:r>
-              <a:rPr lang="en-US" altLang="ja-JP" sz="2000" dirty="0">
-                <a:solidFill>
-                  <a:srgbClr val="000000"/>
-                </a:solidFill>
-                <a:ea typeface="ＭＳ Ｐゴシック" pitchFamily="50" charset="-128"/>
-                <a:hlinkClick r:id="rId2"/>
-              </a:rPr>
-              <a:t>neal.probert@nissan-usa.com</a:t>
-            </a:r>
-            <a:r>
-              <a:rPr lang="en-US" altLang="ja-JP" sz="2000" dirty="0">
-                <a:solidFill>
-                  <a:srgbClr val="000000"/>
-                </a:solidFill>
-                <a:ea typeface="ＭＳ Ｐゴシック" pitchFamily="50" charset="-128"/>
-              </a:rPr>
-              <a:t> </a:t>
-            </a:r>
-          </a:p>
-          <a:p>
-            <a:pPr lvl="0" fontAlgn="base">
-              <a:lnSpc>
-                <a:spcPct val="100000"/>
-              </a:lnSpc>
-              <a:spcBef>
-                <a:spcPct val="0"/>
-              </a:spcBef>
-              <a:spcAft>
-                <a:spcPct val="0"/>
-              </a:spcAft>
-              <a:buFont typeface="Wingdings" panose="05000000000000000000" pitchFamily="2" charset="2"/>
-              <a:buChar char="§"/>
-            </a:pPr>
-            <a:r>
-              <a:rPr lang="en-US" altLang="ja-JP" sz="2000" dirty="0">
-                <a:solidFill>
-                  <a:srgbClr val="000000"/>
-                </a:solidFill>
-                <a:ea typeface="ＭＳ Ｐゴシック" pitchFamily="50" charset="-128"/>
-              </a:rPr>
-              <a:t>NNA VSOC Lead, Senior Cybersecurity Engineer</a:t>
-            </a:r>
-          </a:p>
-          <a:p>
-            <a:pPr lvl="0" fontAlgn="base">
-              <a:lnSpc>
-                <a:spcPct val="100000"/>
-              </a:lnSpc>
-              <a:spcBef>
-                <a:spcPct val="0"/>
-              </a:spcBef>
-              <a:spcAft>
-                <a:spcPct val="0"/>
-              </a:spcAft>
-              <a:buFont typeface="Wingdings" panose="05000000000000000000" pitchFamily="2" charset="2"/>
-              <a:buChar char="§"/>
-            </a:pPr>
-            <a:r>
-              <a:rPr lang="en-US" altLang="ja-JP" sz="2000" dirty="0">
-                <a:solidFill>
-                  <a:srgbClr val="000000"/>
-                </a:solidFill>
-                <a:ea typeface="ＭＳ Ｐゴシック" pitchFamily="50" charset="-128"/>
-              </a:rPr>
-              <a:t>Nissan Technical Center North America (NTCNA)</a:t>
-            </a:r>
-          </a:p>
-          <a:p>
-            <a:pPr lvl="0" fontAlgn="base">
-              <a:lnSpc>
-                <a:spcPct val="100000"/>
-              </a:lnSpc>
-              <a:spcBef>
-                <a:spcPct val="0"/>
-              </a:spcBef>
-              <a:spcAft>
-                <a:spcPct val="0"/>
-              </a:spcAft>
-              <a:buFont typeface="Wingdings" panose="05000000000000000000" pitchFamily="2" charset="2"/>
-              <a:buChar char="§"/>
-            </a:pPr>
-            <a:r>
-              <a:rPr lang="en-US" altLang="ja-JP" sz="2000" dirty="0">
-                <a:solidFill>
-                  <a:srgbClr val="000000"/>
-                </a:solidFill>
-                <a:ea typeface="ＭＳ Ｐゴシック" pitchFamily="50" charset="-128"/>
-              </a:rPr>
-              <a:t>Research &amp; Development, Technical Planning &amp; Research</a:t>
-            </a:r>
-          </a:p>
-          <a:p>
-            <a:pPr lvl="0" fontAlgn="base">
-              <a:lnSpc>
-                <a:spcPct val="100000"/>
-              </a:lnSpc>
-              <a:spcBef>
-                <a:spcPct val="0"/>
-              </a:spcBef>
-              <a:spcAft>
-                <a:spcPct val="0"/>
-              </a:spcAft>
-              <a:buFont typeface="Wingdings" panose="05000000000000000000" pitchFamily="2" charset="2"/>
-              <a:buChar char="§"/>
-            </a:pPr>
-            <a:r>
-              <a:rPr lang="en-US" sz="2000" dirty="0">
-                <a:hlinkClick r:id="rId3"/>
-              </a:rPr>
-              <a:t>Neal Probert - Nissan Technical Center North America | LinkedIn</a:t>
-            </a:r>
-            <a:endParaRPr lang="en-US" altLang="ja-JP" sz="2000" dirty="0">
-              <a:solidFill>
-                <a:srgbClr val="000000"/>
-              </a:solidFill>
-              <a:ea typeface="ＭＳ Ｐゴシック" pitchFamily="50" charset="-128"/>
-            </a:endParaRPr>
-          </a:p>
-          <a:p>
-            <a:pPr lvl="0" fontAlgn="base">
-              <a:lnSpc>
-                <a:spcPct val="100000"/>
-              </a:lnSpc>
-              <a:spcBef>
-                <a:spcPct val="0"/>
-              </a:spcBef>
-              <a:spcAft>
-                <a:spcPct val="0"/>
-              </a:spcAft>
-              <a:buFont typeface="Wingdings" panose="05000000000000000000" pitchFamily="2" charset="2"/>
-              <a:buChar char="§"/>
-            </a:pPr>
-            <a:r>
-              <a:rPr lang="en-US" altLang="ja-JP" sz="2000" dirty="0">
-                <a:solidFill>
-                  <a:srgbClr val="000000"/>
-                </a:solidFill>
-                <a:ea typeface="ＭＳ Ｐゴシック" pitchFamily="50" charset="-128"/>
-              </a:rPr>
-              <a:t>Auto-ISAC PoC for Nissan</a:t>
-            </a:r>
-          </a:p>
-          <a:p>
-            <a:pPr lvl="0" fontAlgn="base">
-              <a:lnSpc>
-                <a:spcPct val="100000"/>
-              </a:lnSpc>
-              <a:spcBef>
-                <a:spcPct val="0"/>
-              </a:spcBef>
-              <a:spcAft>
-                <a:spcPct val="0"/>
-              </a:spcAft>
-              <a:buFont typeface="Wingdings" panose="05000000000000000000" pitchFamily="2" charset="2"/>
-              <a:buChar char="§"/>
-            </a:pPr>
-            <a:endParaRPr lang="en-US" altLang="ja-JP" sz="2000" dirty="0">
-              <a:solidFill>
-                <a:srgbClr val="000000"/>
-              </a:solidFill>
-              <a:ea typeface="ＭＳ Ｐゴシック" pitchFamily="50" charset="-128"/>
-            </a:endParaRPr>
-          </a:p>
-          <a:p>
-            <a:pPr fontAlgn="base">
-              <a:lnSpc>
-                <a:spcPct val="100000"/>
-              </a:lnSpc>
-              <a:spcBef>
-                <a:spcPct val="0"/>
-              </a:spcBef>
-              <a:spcAft>
-                <a:spcPct val="0"/>
-              </a:spcAft>
-            </a:pPr>
-            <a:r>
-              <a:rPr lang="en-US" altLang="ja-JP" sz="1800" dirty="0">
-                <a:solidFill>
-                  <a:srgbClr val="000000"/>
-                </a:solidFill>
-                <a:ea typeface="ＭＳ Ｐゴシック" pitchFamily="50" charset="-128"/>
-              </a:rPr>
-              <a:t>Auto-ISAC Certified Automotive Security Engineer (CASE)</a:t>
-            </a:r>
-          </a:p>
-          <a:p>
-            <a:pPr fontAlgn="base">
-              <a:lnSpc>
-                <a:spcPct val="100000"/>
-              </a:lnSpc>
-              <a:spcBef>
-                <a:spcPct val="0"/>
-              </a:spcBef>
-              <a:spcAft>
-                <a:spcPct val="0"/>
-              </a:spcAft>
-            </a:pPr>
-            <a:r>
-              <a:rPr lang="en-US" altLang="ja-JP" sz="1800" dirty="0">
-                <a:solidFill>
-                  <a:srgbClr val="000000"/>
-                </a:solidFill>
-                <a:ea typeface="ＭＳ Ｐゴシック" pitchFamily="50" charset="-128"/>
-              </a:rPr>
-              <a:t>Auto-ISAC ACT Advanced Wireless Lab instructor</a:t>
-            </a:r>
-          </a:p>
-          <a:p>
-            <a:pPr fontAlgn="base">
-              <a:lnSpc>
-                <a:spcPct val="100000"/>
-              </a:lnSpc>
-              <a:spcBef>
-                <a:spcPct val="0"/>
-              </a:spcBef>
-              <a:spcAft>
-                <a:spcPct val="0"/>
-              </a:spcAft>
-            </a:pPr>
-            <a:r>
-              <a:rPr lang="en-US" altLang="ja-JP" sz="1800" dirty="0">
-                <a:solidFill>
-                  <a:srgbClr val="000000"/>
-                </a:solidFill>
-                <a:ea typeface="ＭＳ Ｐゴシック" pitchFamily="50" charset="-128"/>
-              </a:rPr>
-              <a:t>SAE 21434 Automotive Cybersecurity Certification (ACC) L1 &amp; L2</a:t>
-            </a:r>
-          </a:p>
-          <a:p>
-            <a:pPr marL="0" lvl="0" indent="0" fontAlgn="base">
-              <a:lnSpc>
-                <a:spcPct val="100000"/>
-              </a:lnSpc>
-              <a:spcBef>
-                <a:spcPct val="0"/>
-              </a:spcBef>
-              <a:spcAft>
-                <a:spcPct val="0"/>
-              </a:spcAft>
-              <a:buNone/>
-            </a:pPr>
-            <a:endParaRPr lang="en-US" altLang="ja-JP" sz="1800" dirty="0">
-              <a:solidFill>
-                <a:srgbClr val="000000"/>
-              </a:solidFill>
-              <a:ea typeface="ＭＳ Ｐゴシック" pitchFamily="50" charset="-128"/>
-            </a:endParaRPr>
-          </a:p>
-          <a:p>
-            <a:pPr marL="0" lvl="0" indent="0" fontAlgn="base">
-              <a:lnSpc>
-                <a:spcPct val="100000"/>
-              </a:lnSpc>
-              <a:spcBef>
-                <a:spcPct val="0"/>
-              </a:spcBef>
-              <a:spcAft>
-                <a:spcPct val="0"/>
-              </a:spcAft>
-              <a:buNone/>
-            </a:pPr>
-            <a:r>
-              <a:rPr lang="en-US" altLang="ja-JP" sz="1600" dirty="0">
-                <a:solidFill>
-                  <a:srgbClr val="000000"/>
-                </a:solidFill>
-                <a:ea typeface="ＭＳ Ｐゴシック" pitchFamily="50" charset="-128"/>
-              </a:rPr>
-              <a:t>At Nissan, prior to Cybersecurity I was heavily involved in Vehicle to Vehicle (V2V) and Vehicle to Infrastructure (V2I) work with the Crash Avoidance Metrics Partnership (CAMP) with multiple OEMs.  Btw, my career started out at Ford Research where I got the Henry Ford Technology Award.</a:t>
-            </a:r>
-          </a:p>
-          <a:p>
-            <a:pPr marL="0" lvl="0" indent="0" fontAlgn="base">
-              <a:lnSpc>
-                <a:spcPct val="100000"/>
-              </a:lnSpc>
-              <a:spcBef>
-                <a:spcPct val="0"/>
-              </a:spcBef>
-              <a:spcAft>
-                <a:spcPct val="0"/>
-              </a:spcAft>
-              <a:buNone/>
-            </a:pPr>
-            <a:endParaRPr lang="en-US" altLang="ja-JP" sz="1600" dirty="0">
-              <a:solidFill>
-                <a:srgbClr val="000000"/>
-              </a:solidFill>
-              <a:ea typeface="ＭＳ Ｐゴシック" pitchFamily="50" charset="-128"/>
-            </a:endParaRPr>
-          </a:p>
-          <a:p>
-            <a:pPr marL="0" lvl="0" indent="0" fontAlgn="base">
-              <a:lnSpc>
-                <a:spcPct val="100000"/>
-              </a:lnSpc>
-              <a:spcBef>
-                <a:spcPct val="0"/>
-              </a:spcBef>
-              <a:spcAft>
-                <a:spcPct val="0"/>
-              </a:spcAft>
-              <a:buNone/>
-            </a:pPr>
-            <a:r>
-              <a:rPr lang="en-US" altLang="ja-JP" sz="1600" dirty="0">
-                <a:solidFill>
-                  <a:srgbClr val="000000"/>
-                </a:solidFill>
-                <a:ea typeface="ＭＳ Ｐゴシック" pitchFamily="50" charset="-128"/>
-              </a:rPr>
-              <a:t>My background is in Software Engineering and Networking.  I have worked as a software developer and system/network administrator.</a:t>
-            </a:r>
-          </a:p>
-          <a:p>
-            <a:pPr marL="0" lvl="0" indent="0" fontAlgn="base">
-              <a:lnSpc>
-                <a:spcPct val="100000"/>
-              </a:lnSpc>
-              <a:spcBef>
-                <a:spcPct val="0"/>
-              </a:spcBef>
-              <a:spcAft>
-                <a:spcPct val="0"/>
-              </a:spcAft>
-              <a:buNone/>
-            </a:pPr>
-            <a:endParaRPr lang="en-US" altLang="ja-JP" sz="1600" dirty="0">
-              <a:solidFill>
-                <a:srgbClr val="000000"/>
-              </a:solidFill>
-              <a:ea typeface="ＭＳ Ｐゴシック" pitchFamily="50" charset="-128"/>
-            </a:endParaRPr>
-          </a:p>
-          <a:p>
-            <a:pPr marL="0" lvl="0" indent="0" fontAlgn="base">
-              <a:lnSpc>
-                <a:spcPct val="100000"/>
-              </a:lnSpc>
-              <a:spcBef>
-                <a:spcPct val="0"/>
-              </a:spcBef>
-              <a:spcAft>
-                <a:spcPct val="0"/>
-              </a:spcAft>
-              <a:buNone/>
-            </a:pPr>
-            <a:r>
-              <a:rPr lang="en-US" altLang="ja-JP" sz="1600" dirty="0">
-                <a:solidFill>
-                  <a:srgbClr val="000000"/>
-                </a:solidFill>
-                <a:ea typeface="ＭＳ Ｐゴシック" pitchFamily="50" charset="-128"/>
-              </a:rPr>
-              <a:t>Linux/Unix, Python, C/C++, Java, PHP, Perl, SQL, …</a:t>
-            </a:r>
-          </a:p>
-          <a:p>
-            <a:pPr marL="0" lvl="0" indent="0" fontAlgn="base">
-              <a:lnSpc>
-                <a:spcPct val="100000"/>
-              </a:lnSpc>
-              <a:spcBef>
-                <a:spcPct val="0"/>
-              </a:spcBef>
-              <a:spcAft>
-                <a:spcPct val="0"/>
-              </a:spcAft>
-              <a:buNone/>
-            </a:pPr>
-            <a:r>
-              <a:rPr lang="en-US" altLang="ja-JP" sz="1600" dirty="0">
-                <a:solidFill>
-                  <a:srgbClr val="000000"/>
-                </a:solidFill>
-                <a:ea typeface="ＭＳ Ｐゴシック" pitchFamily="50" charset="-128"/>
-              </a:rPr>
-              <a:t>HAM Radio: KD8NVN</a:t>
-            </a:r>
-          </a:p>
-        </p:txBody>
-      </p:sp>
-      <p:pic>
-        <p:nvPicPr>
-          <p:cNvPr id="5" name="Picture 4">
-            <a:extLst>
-              <a:ext uri="{FF2B5EF4-FFF2-40B4-BE49-F238E27FC236}">
-                <a16:creationId xmlns:a16="http://schemas.microsoft.com/office/drawing/2014/main" id="{AEB9037B-06A8-6C69-8656-2EE1EF2AADE8}"/>
-              </a:ext>
-            </a:extLst>
-          </p:cNvPr>
-          <p:cNvPicPr>
-            <a:picLocks noChangeAspect="1"/>
-          </p:cNvPicPr>
-          <p:nvPr/>
-        </p:nvPicPr>
-        <p:blipFill>
-          <a:blip r:embed="rId4" cstate="print">
-            <a:extLst>
-              <a:ext uri="{28A0092B-C50C-407E-A947-70E740481C1C}">
-                <a14:useLocalDpi xmlns:a14="http://schemas.microsoft.com/office/drawing/2010/main" val="0"/>
-              </a:ext>
-            </a:extLst>
-          </a:blip>
-          <a:stretch>
-            <a:fillRect/>
-          </a:stretch>
-        </p:blipFill>
-        <p:spPr>
-          <a:xfrm rot="16200000">
-            <a:off x="9312276" y="1179261"/>
-            <a:ext cx="2413000" cy="1809750"/>
-          </a:xfrm>
-          <a:prstGeom prst="rect">
-            <a:avLst/>
-          </a:prstGeom>
-        </p:spPr>
-      </p:pic>
-    </p:spTree>
-    <p:extLst>
-      <p:ext uri="{BB962C8B-B14F-4D97-AF65-F5344CB8AC3E}">
-        <p14:creationId xmlns:p14="http://schemas.microsoft.com/office/powerpoint/2010/main" val="3694643168"/>
-      </p:ext>
-    </p:extLst>
-  </p:cSld>
-  <p:clrMapOvr>
-    <a:masterClrMapping/>
-  </p:clrMapOvr>
-</p:sld>
-</file>
-
-<file path=ppt/slides/slide2.xml><?xml version="1.0" encoding="utf-8"?>
-<p:sld xmlns:a="http://schemas.openxmlformats.org/drawingml/2006/main" xmlns:r="http://schemas.openxmlformats.org/officeDocument/2006/relationships" xmlns:p="http://schemas.openxmlformats.org/presentationml/2006/main">
-  <p:cSld>
-    <p:spTree>
-      <p:nvGrpSpPr>
         <p:cNvPr id="1" name=""/>
         <p:cNvGrpSpPr/>
         <p:nvPr/>
@@ -6799,7 +6233,7 @@
           <a:p>
             <a:r>
               <a:rPr lang="en-US" dirty="0"/>
-              <a:t>But if you want to DYI on your own laptop (Windows 10/11), here are some instructions to get started:</a:t>
+              <a:t>But if you want to DYI on your own laptop (Windows 10/11 or even Linux), here are some instructions to get started:</a:t>
             </a:r>
           </a:p>
           <a:p>
@@ -6826,7 +6260,7 @@
             </a:pPr>
             <a:r>
               <a:rPr lang="en-US" dirty="0"/>
-              <a:t>Download both the Windows hosts platform package and the VirtualBox Extension Pack</a:t>
+              <a:t>Download both the Windows (or Linux) hosts platform package and the VirtualBox Extension Pack</a:t>
             </a:r>
           </a:p>
           <a:p>
@@ -6905,7 +6339,7 @@
 </p:sld>
 </file>
 
-<file path=ppt/slides/slide3.xml><?xml version="1.0" encoding="utf-8"?>
+<file path=ppt/slides/slide2.xml><?xml version="1.0" encoding="utf-8"?>
 <p:sld xmlns:a="http://schemas.openxmlformats.org/drawingml/2006/main" xmlns:r="http://schemas.openxmlformats.org/officeDocument/2006/relationships" xmlns:p="http://schemas.openxmlformats.org/presentationml/2006/main">
   <p:cSld>
     <p:spTree>
@@ -7060,7 +6494,7 @@
             <a:pPr marL="971550" lvl="1" indent="-285750"/>
             <a:r>
               <a:rPr lang="en-US" sz="1600" dirty="0"/>
-              <a:t>This gets you a Kali Linux that boots up on your Laptop</a:t>
+              <a:t>This gets you a Kali Linux that boots up on your Laptop or Workstation</a:t>
             </a:r>
           </a:p>
           <a:p>
@@ -7114,2514 +6548,10 @@
 </p:sld>
 </file>
 
-<file path=ppt/slides/slide4.xml><?xml version="1.0" encoding="utf-8"?>
-<p:sld xmlns:a="http://schemas.openxmlformats.org/drawingml/2006/main" xmlns:r="http://schemas.openxmlformats.org/officeDocument/2006/relationships" xmlns:p="http://schemas.openxmlformats.org/presentationml/2006/main">
-  <p:cSld>
-    <p:spTree>
-      <p:nvGrpSpPr>
-        <p:cNvPr id="1" name=""/>
-        <p:cNvGrpSpPr/>
-        <p:nvPr/>
-      </p:nvGrpSpPr>
-      <p:grpSpPr>
-        <a:xfrm>
-          <a:off x="0" y="0"/>
-          <a:ext cx="0" cy="0"/>
-          <a:chOff x="0" y="0"/>
-          <a:chExt cx="0" cy="0"/>
-        </a:xfrm>
-      </p:grpSpPr>
-      <p:sp>
-        <p:nvSpPr>
-          <p:cNvPr id="2" name="Text Placeholder 1">
-            <a:extLst>
-              <a:ext uri="{FF2B5EF4-FFF2-40B4-BE49-F238E27FC236}">
-                <a16:creationId xmlns:a16="http://schemas.microsoft.com/office/drawing/2014/main" id="{168CC41A-92DC-4526-9165-E4D3020A5F9A}"/>
-              </a:ext>
-            </a:extLst>
-          </p:cNvPr>
-          <p:cNvSpPr>
-            <a:spLocks noGrp="1"/>
-          </p:cNvSpPr>
-          <p:nvPr>
-            <p:ph type="body" sz="quarter" idx="10"/>
-          </p:nvPr>
-        </p:nvSpPr>
-        <p:spPr/>
-        <p:txBody>
-          <a:bodyPr/>
-          <a:lstStyle/>
-          <a:p>
-            <a:r>
-              <a:rPr lang="en-US" dirty="0"/>
-              <a:t>Auto-ISAC ACT Advanced Wireless Lab - 2026</a:t>
-            </a:r>
-          </a:p>
-        </p:txBody>
-      </p:sp>
-      <p:sp>
-        <p:nvSpPr>
-          <p:cNvPr id="4" name="Text Placeholder 3">
-            <a:extLst>
-              <a:ext uri="{FF2B5EF4-FFF2-40B4-BE49-F238E27FC236}">
-                <a16:creationId xmlns:a16="http://schemas.microsoft.com/office/drawing/2014/main" id="{37CF222F-449F-AEF7-61FD-D75CFCD9EC5D}"/>
-              </a:ext>
-            </a:extLst>
-          </p:cNvPr>
-          <p:cNvSpPr>
-            <a:spLocks noGrp="1"/>
-          </p:cNvSpPr>
-          <p:nvPr>
-            <p:ph type="body" sz="quarter" idx="12"/>
-          </p:nvPr>
-        </p:nvSpPr>
-        <p:spPr>
-          <a:xfrm>
-            <a:off x="270415" y="717259"/>
-            <a:ext cx="11658059" cy="5327941"/>
-          </a:xfrm>
-        </p:spPr>
-        <p:txBody>
-          <a:bodyPr>
-            <a:normAutofit fontScale="92500" lnSpcReduction="20000"/>
-          </a:bodyPr>
-          <a:lstStyle/>
-          <a:p>
-            <a:pPr marL="285750" indent="-285750">
-              <a:buFont typeface="Arial" panose="020B0604020202020204" pitchFamily="34" charset="0"/>
-              <a:buChar char="•"/>
-            </a:pPr>
-            <a:r>
-              <a:rPr lang="en-US" sz="1600" b="1" dirty="0"/>
-              <a:t>FCC ID</a:t>
-            </a:r>
-          </a:p>
-          <a:p>
-            <a:pPr marL="971550" lvl="1" indent="-285750"/>
-            <a:r>
-              <a:rPr lang="en-US" sz="1300" dirty="0"/>
-              <a:t>Lookup</a:t>
-            </a:r>
-          </a:p>
-          <a:p>
-            <a:pPr marL="285750" indent="-285750">
-              <a:buFont typeface="Arial" panose="020B0604020202020204" pitchFamily="34" charset="0"/>
-              <a:buChar char="•"/>
-            </a:pPr>
-            <a:r>
-              <a:rPr lang="en-US" sz="1600" b="1" dirty="0"/>
-              <a:t>Bluetooth</a:t>
-            </a:r>
-          </a:p>
-          <a:p>
-            <a:pPr marL="971550" lvl="1" indent="-285750"/>
-            <a:r>
-              <a:rPr lang="en-US" sz="1400" dirty="0"/>
-              <a:t>Scanning</a:t>
-            </a:r>
-          </a:p>
-          <a:p>
-            <a:pPr marL="971550" lvl="1" indent="-285750"/>
-            <a:r>
-              <a:rPr lang="en-US" sz="1400" dirty="0"/>
-              <a:t>Enumerating</a:t>
-            </a:r>
-          </a:p>
-          <a:p>
-            <a:pPr marL="971550" lvl="1" indent="-285750"/>
-            <a:r>
-              <a:rPr lang="en-US" sz="1400" dirty="0"/>
-              <a:t>Identifying</a:t>
-            </a:r>
-          </a:p>
-          <a:p>
-            <a:pPr marL="971550" lvl="1" indent="-285750"/>
-            <a:r>
-              <a:rPr lang="en-US" sz="1400" dirty="0"/>
-              <a:t>Analyzing</a:t>
-            </a:r>
-          </a:p>
-          <a:p>
-            <a:pPr marL="971550" lvl="1" indent="-285750"/>
-            <a:r>
-              <a:rPr lang="en-US" sz="1400" dirty="0"/>
-              <a:t>Pairing</a:t>
-            </a:r>
-          </a:p>
-          <a:p>
-            <a:pPr marL="971550" lvl="1" indent="-285750"/>
-            <a:r>
-              <a:rPr lang="en-US" sz="1400" dirty="0"/>
-              <a:t>Data</a:t>
-            </a:r>
-          </a:p>
-          <a:p>
-            <a:pPr marL="285750" indent="-285750">
-              <a:buFont typeface="Arial" panose="020B0604020202020204" pitchFamily="34" charset="0"/>
-              <a:buChar char="•"/>
-            </a:pPr>
-            <a:r>
-              <a:rPr lang="en-US" sz="1600" b="1" dirty="0" err="1"/>
-              <a:t>WiFi</a:t>
-            </a:r>
-            <a:endParaRPr lang="en-US" sz="1600" b="1" dirty="0"/>
-          </a:p>
-          <a:p>
-            <a:pPr marL="971550" lvl="1" indent="-285750"/>
-            <a:r>
-              <a:rPr lang="en-US" sz="1400" dirty="0"/>
-              <a:t>Analyzer</a:t>
-            </a:r>
-          </a:p>
-          <a:p>
-            <a:pPr marL="971550" lvl="1" indent="-285750"/>
-            <a:r>
-              <a:rPr lang="en-US" sz="1400" dirty="0" err="1"/>
-              <a:t>WiFite</a:t>
-            </a:r>
-            <a:endParaRPr lang="en-US" sz="1400" dirty="0"/>
-          </a:p>
-          <a:p>
-            <a:pPr marL="971550" lvl="1" indent="-285750"/>
-            <a:r>
-              <a:rPr lang="en-US" sz="1400" dirty="0" err="1"/>
-              <a:t>HackISAC</a:t>
-            </a:r>
-            <a:endParaRPr lang="en-US" sz="1400" dirty="0"/>
-          </a:p>
-          <a:p>
-            <a:pPr marL="285750" indent="-285750">
-              <a:buFont typeface="Arial" panose="020B0604020202020204" pitchFamily="34" charset="0"/>
-              <a:buChar char="•"/>
-            </a:pPr>
-            <a:r>
-              <a:rPr lang="en-US" sz="1600" b="1" dirty="0"/>
-              <a:t>SDR</a:t>
-            </a:r>
-          </a:p>
-          <a:p>
-            <a:pPr marL="971550" lvl="1" indent="-285750"/>
-            <a:r>
-              <a:rPr lang="en-US" sz="1400" dirty="0"/>
-              <a:t>FM Radio</a:t>
-            </a:r>
-          </a:p>
-          <a:p>
-            <a:pPr marL="971550" lvl="1" indent="-285750"/>
-            <a:r>
-              <a:rPr lang="en-US" sz="1400" dirty="0" err="1"/>
-              <a:t>Keyfob</a:t>
-            </a:r>
-            <a:r>
-              <a:rPr lang="en-US" sz="1400" dirty="0"/>
-              <a:t> record</a:t>
-            </a:r>
-          </a:p>
-          <a:p>
-            <a:pPr marL="971550" lvl="1" indent="-285750"/>
-            <a:r>
-              <a:rPr lang="en-US" sz="1400" dirty="0" err="1"/>
-              <a:t>Keyfob</a:t>
-            </a:r>
-            <a:r>
-              <a:rPr lang="en-US" sz="1400" dirty="0"/>
-              <a:t> replay</a:t>
-            </a:r>
-          </a:p>
-          <a:p>
-            <a:pPr marL="971550" lvl="1" indent="-285750"/>
-            <a:r>
-              <a:rPr lang="en-US" sz="1400" dirty="0" err="1"/>
-              <a:t>Keyfob</a:t>
-            </a:r>
-            <a:r>
-              <a:rPr lang="en-US" sz="1400" dirty="0"/>
-              <a:t> decode</a:t>
-            </a:r>
-          </a:p>
-          <a:p>
-            <a:pPr marL="285750" indent="-285750">
-              <a:buFont typeface="Arial" panose="020B0604020202020204" pitchFamily="34" charset="0"/>
-              <a:buChar char="•"/>
-            </a:pPr>
-            <a:r>
-              <a:rPr lang="en-US" sz="1600" b="1" dirty="0"/>
-              <a:t>GPS</a:t>
-            </a:r>
-          </a:p>
-          <a:p>
-            <a:pPr marL="971550" lvl="1" indent="-285750"/>
-            <a:r>
-              <a:rPr lang="en-US" sz="1400" dirty="0"/>
-              <a:t>Viewing</a:t>
-            </a:r>
-            <a:endParaRPr lang="en-US" sz="800" dirty="0"/>
-          </a:p>
-          <a:p>
-            <a:pPr marL="285750" indent="-285750">
-              <a:buFont typeface="Arial" panose="020B0604020202020204" pitchFamily="34" charset="0"/>
-              <a:buChar char="•"/>
-            </a:pPr>
-            <a:r>
-              <a:rPr lang="en-US" sz="1600" b="1" dirty="0"/>
-              <a:t>V2X</a:t>
-            </a:r>
-          </a:p>
-          <a:p>
-            <a:pPr marL="971550" lvl="1" indent="-285750"/>
-            <a:r>
-              <a:rPr lang="en-US" sz="1300" dirty="0"/>
-              <a:t>Overview</a:t>
-            </a:r>
-          </a:p>
-          <a:p>
-            <a:pPr marL="285750" indent="-285750"/>
-            <a:endParaRPr lang="en-US" sz="800" dirty="0"/>
-          </a:p>
-        </p:txBody>
-      </p:sp>
-    </p:spTree>
-    <p:extLst>
-      <p:ext uri="{BB962C8B-B14F-4D97-AF65-F5344CB8AC3E}">
-        <p14:creationId xmlns:p14="http://schemas.microsoft.com/office/powerpoint/2010/main" val="1194985742"/>
-      </p:ext>
-    </p:extLst>
-  </p:cSld>
-  <p:clrMapOvr>
-    <a:masterClrMapping/>
-  </p:clrMapOvr>
-</p:sld>
-</file>
-
-<file path=ppt/slides/slide5.xml><?xml version="1.0" encoding="utf-8"?>
-<p:sld xmlns:a="http://schemas.openxmlformats.org/drawingml/2006/main" xmlns:r="http://schemas.openxmlformats.org/officeDocument/2006/relationships" xmlns:p="http://schemas.openxmlformats.org/presentationml/2006/main" showMasterSp="0">
-  <p:cSld>
-    <p:spTree>
-      <p:nvGrpSpPr>
-        <p:cNvPr id="1" name=""/>
-        <p:cNvGrpSpPr/>
-        <p:nvPr/>
-      </p:nvGrpSpPr>
-      <p:grpSpPr>
-        <a:xfrm>
-          <a:off x="0" y="0"/>
-          <a:ext cx="0" cy="0"/>
-          <a:chOff x="0" y="0"/>
-          <a:chExt cx="0" cy="0"/>
-        </a:xfrm>
-      </p:grpSpPr>
-      <p:sp>
-        <p:nvSpPr>
-          <p:cNvPr id="2" name="object 2" descr="$PPTXTitle"/>
-          <p:cNvSpPr txBox="1"/>
-          <p:nvPr/>
-        </p:nvSpPr>
-        <p:spPr>
-          <a:xfrm>
-            <a:off x="398667" y="509412"/>
-            <a:ext cx="5933440" cy="632651"/>
-          </a:xfrm>
-          <a:prstGeom prst="rect">
-            <a:avLst/>
-          </a:prstGeom>
-        </p:spPr>
-        <p:txBody>
-          <a:bodyPr vert="horz" wrap="square" lIns="0" tIns="16933" rIns="0" bIns="0" rtlCol="0">
-            <a:spAutoFit/>
-          </a:bodyPr>
-          <a:lstStyle/>
-          <a:p>
-            <a:pPr marL="16933" defTabSz="1219170">
-              <a:spcBef>
-                <a:spcPts val="133"/>
-              </a:spcBef>
-            </a:pPr>
-            <a:r>
-              <a:rPr sz="4000" kern="0" dirty="0">
-                <a:solidFill>
-                  <a:srgbClr val="595959"/>
-                </a:solidFill>
-                <a:latin typeface="Roboto"/>
-                <a:cs typeface="Roboto"/>
-              </a:rPr>
-              <a:t>FCCID</a:t>
-            </a:r>
-            <a:r>
-              <a:rPr sz="4000" kern="0" spc="-80" dirty="0">
-                <a:solidFill>
-                  <a:srgbClr val="595959"/>
-                </a:solidFill>
-                <a:latin typeface="Roboto"/>
-                <a:cs typeface="Roboto"/>
-              </a:rPr>
-              <a:t> </a:t>
-            </a:r>
-            <a:r>
-              <a:rPr sz="4000" kern="0" dirty="0">
-                <a:solidFill>
-                  <a:srgbClr val="595959"/>
-                </a:solidFill>
-                <a:latin typeface="Roboto"/>
-                <a:cs typeface="Roboto"/>
-              </a:rPr>
-              <a:t>Lookup</a:t>
-            </a:r>
-            <a:r>
-              <a:rPr sz="4000" kern="0" spc="-60" dirty="0">
-                <a:solidFill>
-                  <a:srgbClr val="595959"/>
-                </a:solidFill>
-                <a:latin typeface="Roboto"/>
-                <a:cs typeface="Roboto"/>
-              </a:rPr>
-              <a:t> </a:t>
-            </a:r>
-            <a:r>
-              <a:rPr sz="4000" kern="0" dirty="0">
-                <a:solidFill>
-                  <a:srgbClr val="2A3890"/>
-                </a:solidFill>
-                <a:latin typeface="Roboto"/>
-                <a:cs typeface="Roboto"/>
-              </a:rPr>
-              <a:t>–</a:t>
-            </a:r>
-            <a:r>
-              <a:rPr sz="4000" kern="0" spc="-80" dirty="0">
-                <a:solidFill>
-                  <a:srgbClr val="2A3890"/>
-                </a:solidFill>
-                <a:latin typeface="Roboto"/>
-                <a:cs typeface="Roboto"/>
-              </a:rPr>
-              <a:t> </a:t>
-            </a:r>
-            <a:r>
-              <a:rPr sz="4000" kern="0" spc="-13" dirty="0">
-                <a:solidFill>
-                  <a:srgbClr val="2A3890"/>
-                </a:solidFill>
-                <a:latin typeface="Roboto"/>
-                <a:cs typeface="Roboto"/>
-              </a:rPr>
-              <a:t>Research</a:t>
-            </a:r>
-            <a:endParaRPr sz="4000" kern="0">
-              <a:solidFill>
-                <a:sysClr val="windowText" lastClr="000000"/>
-              </a:solidFill>
-              <a:latin typeface="Roboto"/>
-              <a:cs typeface="Roboto"/>
-            </a:endParaRPr>
-          </a:p>
-        </p:txBody>
-      </p:sp>
-      <p:grpSp>
-        <p:nvGrpSpPr>
-          <p:cNvPr id="3" name="object 3"/>
-          <p:cNvGrpSpPr/>
-          <p:nvPr/>
-        </p:nvGrpSpPr>
-        <p:grpSpPr>
-          <a:xfrm>
-            <a:off x="791449" y="1292220"/>
-            <a:ext cx="2337647" cy="4785360"/>
-            <a:chOff x="593586" y="969165"/>
-            <a:chExt cx="1753235" cy="3589020"/>
-          </a:xfrm>
-        </p:grpSpPr>
-        <p:pic>
-          <p:nvPicPr>
-            <p:cNvPr id="4" name="object 4"/>
-            <p:cNvPicPr/>
-            <p:nvPr/>
-          </p:nvPicPr>
-          <p:blipFill>
-            <a:blip r:embed="rId3" cstate="email">
-              <a:extLst>
-                <a:ext uri="{28A0092B-C50C-407E-A947-70E740481C1C}">
-                  <a14:useLocalDpi xmlns:a14="http://schemas.microsoft.com/office/drawing/2010/main"/>
-                </a:ext>
-              </a:extLst>
-            </a:blip>
-            <a:stretch>
-              <a:fillRect/>
-            </a:stretch>
-          </p:blipFill>
-          <p:spPr>
-            <a:xfrm>
-              <a:off x="745021" y="1049646"/>
-              <a:ext cx="1490060" cy="3334896"/>
-            </a:xfrm>
-            <a:prstGeom prst="rect">
-              <a:avLst/>
-            </a:prstGeom>
-          </p:spPr>
-        </p:pic>
-        <p:sp>
-          <p:nvSpPr>
-            <p:cNvPr id="5" name="object 5"/>
-            <p:cNvSpPr/>
-            <p:nvPr/>
-          </p:nvSpPr>
-          <p:spPr>
-            <a:xfrm>
-              <a:off x="598348" y="973928"/>
-              <a:ext cx="1743710" cy="3579495"/>
-            </a:xfrm>
-            <a:custGeom>
-              <a:avLst/>
-              <a:gdLst/>
-              <a:ahLst/>
-              <a:cxnLst/>
-              <a:rect l="l" t="t" r="r" b="b"/>
-              <a:pathLst>
-                <a:path w="1743710" h="3579495">
-                  <a:moveTo>
-                    <a:pt x="0" y="0"/>
-                  </a:moveTo>
-                  <a:lnTo>
-                    <a:pt x="1743493" y="0"/>
-                  </a:lnTo>
-                  <a:lnTo>
-                    <a:pt x="1743493" y="3579460"/>
-                  </a:lnTo>
-                  <a:lnTo>
-                    <a:pt x="0" y="3579460"/>
-                  </a:lnTo>
-                  <a:lnTo>
-                    <a:pt x="0" y="0"/>
-                  </a:lnTo>
-                  <a:close/>
-                </a:path>
-              </a:pathLst>
-            </a:custGeom>
-            <a:ln w="9524">
-              <a:solidFill>
-                <a:srgbClr val="212D73"/>
-              </a:solidFill>
-            </a:ln>
-          </p:spPr>
-          <p:txBody>
-            <a:bodyPr wrap="square" lIns="0" tIns="0" rIns="0" bIns="0" rtlCol="0"/>
-            <a:lstStyle/>
-            <a:p>
-              <a:pPr defTabSz="1219170"/>
-              <a:endParaRPr sz="2400" kern="0">
-                <a:solidFill>
-                  <a:sysClr val="windowText" lastClr="000000"/>
-                </a:solidFill>
-              </a:endParaRPr>
-            </a:p>
-          </p:txBody>
-        </p:sp>
-      </p:grpSp>
-      <p:grpSp>
-        <p:nvGrpSpPr>
-          <p:cNvPr id="6" name="object 6"/>
-          <p:cNvGrpSpPr/>
-          <p:nvPr/>
-        </p:nvGrpSpPr>
-        <p:grpSpPr>
-          <a:xfrm>
-            <a:off x="3669344" y="1292220"/>
-            <a:ext cx="2101427" cy="4785360"/>
-            <a:chOff x="2752008" y="969165"/>
-            <a:chExt cx="1576070" cy="3589020"/>
-          </a:xfrm>
-        </p:grpSpPr>
-        <p:pic>
-          <p:nvPicPr>
-            <p:cNvPr id="7" name="object 7"/>
-            <p:cNvPicPr/>
-            <p:nvPr/>
-          </p:nvPicPr>
-          <p:blipFill>
-            <a:blip r:embed="rId4" cstate="email">
-              <a:extLst>
-                <a:ext uri="{28A0092B-C50C-407E-A947-70E740481C1C}">
-                  <a14:useLocalDpi xmlns:a14="http://schemas.microsoft.com/office/drawing/2010/main"/>
-                </a:ext>
-              </a:extLst>
-            </a:blip>
-            <a:stretch>
-              <a:fillRect/>
-            </a:stretch>
-          </p:blipFill>
-          <p:spPr>
-            <a:xfrm>
-              <a:off x="2832489" y="978690"/>
-              <a:ext cx="1419104" cy="3476806"/>
-            </a:xfrm>
-            <a:prstGeom prst="rect">
-              <a:avLst/>
-            </a:prstGeom>
-          </p:spPr>
-        </p:pic>
-        <p:sp>
-          <p:nvSpPr>
-            <p:cNvPr id="8" name="object 8"/>
-            <p:cNvSpPr/>
-            <p:nvPr/>
-          </p:nvSpPr>
-          <p:spPr>
-            <a:xfrm>
-              <a:off x="2756771" y="973928"/>
-              <a:ext cx="1566545" cy="3579495"/>
-            </a:xfrm>
-            <a:custGeom>
-              <a:avLst/>
-              <a:gdLst/>
-              <a:ahLst/>
-              <a:cxnLst/>
-              <a:rect l="l" t="t" r="r" b="b"/>
-              <a:pathLst>
-                <a:path w="1566545" h="3579495">
-                  <a:moveTo>
-                    <a:pt x="0" y="0"/>
-                  </a:moveTo>
-                  <a:lnTo>
-                    <a:pt x="1566105" y="0"/>
-                  </a:lnTo>
-                  <a:lnTo>
-                    <a:pt x="1566105" y="3579460"/>
-                  </a:lnTo>
-                  <a:lnTo>
-                    <a:pt x="0" y="3579460"/>
-                  </a:lnTo>
-                  <a:lnTo>
-                    <a:pt x="0" y="0"/>
-                  </a:lnTo>
-                  <a:close/>
-                </a:path>
-              </a:pathLst>
-            </a:custGeom>
-            <a:ln w="9524">
-              <a:solidFill>
-                <a:srgbClr val="212D73"/>
-              </a:solidFill>
-            </a:ln>
-          </p:spPr>
-          <p:txBody>
-            <a:bodyPr wrap="square" lIns="0" tIns="0" rIns="0" bIns="0" rtlCol="0"/>
-            <a:lstStyle/>
-            <a:p>
-              <a:pPr defTabSz="1219170"/>
-              <a:endParaRPr sz="2400" kern="0">
-                <a:solidFill>
-                  <a:sysClr val="windowText" lastClr="000000"/>
-                </a:solidFill>
-              </a:endParaRPr>
-            </a:p>
-          </p:txBody>
-        </p:sp>
-      </p:grpSp>
-      <p:grpSp>
-        <p:nvGrpSpPr>
-          <p:cNvPr id="9" name="object 9"/>
-          <p:cNvGrpSpPr/>
-          <p:nvPr/>
-        </p:nvGrpSpPr>
-        <p:grpSpPr>
-          <a:xfrm>
-            <a:off x="6158684" y="2116186"/>
-            <a:ext cx="5779347" cy="2810933"/>
-            <a:chOff x="4619013" y="1587139"/>
-            <a:chExt cx="4334510" cy="2108200"/>
-          </a:xfrm>
-        </p:grpSpPr>
-        <p:pic>
-          <p:nvPicPr>
-            <p:cNvPr id="10" name="object 10"/>
-            <p:cNvPicPr/>
-            <p:nvPr/>
-          </p:nvPicPr>
-          <p:blipFill>
-            <a:blip r:embed="rId5" cstate="email">
-              <a:extLst>
-                <a:ext uri="{28A0092B-C50C-407E-A947-70E740481C1C}">
-                  <a14:useLocalDpi xmlns:a14="http://schemas.microsoft.com/office/drawing/2010/main"/>
-                </a:ext>
-              </a:extLst>
-            </a:blip>
-            <a:stretch>
-              <a:fillRect/>
-            </a:stretch>
-          </p:blipFill>
-          <p:spPr>
-            <a:xfrm>
-              <a:off x="4628538" y="1596664"/>
-              <a:ext cx="4315358" cy="2033148"/>
-            </a:xfrm>
-            <a:prstGeom prst="rect">
-              <a:avLst/>
-            </a:prstGeom>
-          </p:spPr>
-        </p:pic>
-        <p:sp>
-          <p:nvSpPr>
-            <p:cNvPr id="11" name="object 11"/>
-            <p:cNvSpPr/>
-            <p:nvPr/>
-          </p:nvSpPr>
-          <p:spPr>
-            <a:xfrm>
-              <a:off x="4623775" y="1591901"/>
-              <a:ext cx="4324985" cy="2098675"/>
-            </a:xfrm>
-            <a:custGeom>
-              <a:avLst/>
-              <a:gdLst/>
-              <a:ahLst/>
-              <a:cxnLst/>
-              <a:rect l="l" t="t" r="r" b="b"/>
-              <a:pathLst>
-                <a:path w="4324984" h="2098675">
-                  <a:moveTo>
-                    <a:pt x="0" y="0"/>
-                  </a:moveTo>
-                  <a:lnTo>
-                    <a:pt x="4324883" y="0"/>
-                  </a:lnTo>
-                  <a:lnTo>
-                    <a:pt x="4324883" y="2098585"/>
-                  </a:lnTo>
-                  <a:lnTo>
-                    <a:pt x="0" y="2098585"/>
-                  </a:lnTo>
-                  <a:lnTo>
-                    <a:pt x="0" y="0"/>
-                  </a:lnTo>
-                  <a:close/>
-                </a:path>
-              </a:pathLst>
-            </a:custGeom>
-            <a:ln w="9524">
-              <a:solidFill>
-                <a:srgbClr val="212D73"/>
-              </a:solidFill>
-            </a:ln>
-          </p:spPr>
-          <p:txBody>
-            <a:bodyPr wrap="square" lIns="0" tIns="0" rIns="0" bIns="0" rtlCol="0"/>
-            <a:lstStyle/>
-            <a:p>
-              <a:pPr defTabSz="1219170"/>
-              <a:endParaRPr sz="2400" kern="0">
-                <a:solidFill>
-                  <a:sysClr val="windowText" lastClr="000000"/>
-                </a:solidFill>
-              </a:endParaRPr>
-            </a:p>
-          </p:txBody>
-        </p:sp>
-      </p:grpSp>
-      <p:sp>
-        <p:nvSpPr>
-          <p:cNvPr id="12" name="object 12"/>
-          <p:cNvSpPr txBox="1"/>
-          <p:nvPr/>
-        </p:nvSpPr>
-        <p:spPr>
-          <a:xfrm>
-            <a:off x="6243370" y="1756718"/>
-            <a:ext cx="2613660" cy="304421"/>
-          </a:xfrm>
-          <a:prstGeom prst="rect">
-            <a:avLst/>
-          </a:prstGeom>
-        </p:spPr>
-        <p:txBody>
-          <a:bodyPr vert="horz" wrap="square" lIns="0" tIns="16933" rIns="0" bIns="0" rtlCol="0">
-            <a:spAutoFit/>
-          </a:bodyPr>
-          <a:lstStyle/>
-          <a:p>
-            <a:pPr marL="16933" defTabSz="1219170">
-              <a:spcBef>
-                <a:spcPts val="133"/>
-              </a:spcBef>
-            </a:pPr>
-            <a:r>
-              <a:rPr sz="1867" b="1" kern="0" dirty="0">
-                <a:solidFill>
-                  <a:srgbClr val="2A3890"/>
-                </a:solidFill>
-                <a:latin typeface="Arial"/>
-                <a:cs typeface="Arial"/>
-              </a:rPr>
-              <a:t>Operating</a:t>
-            </a:r>
-            <a:r>
-              <a:rPr sz="1867" b="1" kern="0" spc="-60" dirty="0">
-                <a:solidFill>
-                  <a:srgbClr val="2A3890"/>
-                </a:solidFill>
-                <a:latin typeface="Arial"/>
-                <a:cs typeface="Arial"/>
-              </a:rPr>
-              <a:t> </a:t>
-            </a:r>
-            <a:r>
-              <a:rPr sz="1867" b="1" kern="0" spc="-13" dirty="0">
-                <a:solidFill>
-                  <a:srgbClr val="2A3890"/>
-                </a:solidFill>
-                <a:latin typeface="Arial"/>
-                <a:cs typeface="Arial"/>
-              </a:rPr>
-              <a:t>Frequencies</a:t>
-            </a:r>
-            <a:endParaRPr sz="1867" kern="0">
-              <a:solidFill>
-                <a:sysClr val="windowText" lastClr="000000"/>
-              </a:solidFill>
-              <a:latin typeface="Arial"/>
-              <a:cs typeface="Arial"/>
-            </a:endParaRPr>
-          </a:p>
-        </p:txBody>
-      </p:sp>
-      <p:sp>
-        <p:nvSpPr>
-          <p:cNvPr id="13" name="object 13"/>
-          <p:cNvSpPr txBox="1">
-            <a:spLocks noGrp="1"/>
-          </p:cNvSpPr>
-          <p:nvPr>
-            <p:ph type="sldNum" sz="quarter" idx="12"/>
-          </p:nvPr>
-        </p:nvSpPr>
-        <p:spPr>
-          <a:prstGeom prst="rect">
-            <a:avLst/>
-          </a:prstGeom>
-        </p:spPr>
-        <p:txBody>
-          <a:bodyPr vert="horz" wrap="square" lIns="0" tIns="0" rIns="0" bIns="0" rtlCol="0">
-            <a:spAutoFit/>
-          </a:bodyPr>
-          <a:lstStyle/>
-          <a:p>
-            <a:pPr marL="50799" defTabSz="1219170">
-              <a:lnSpc>
-                <a:spcPts val="2193"/>
-              </a:lnSpc>
-            </a:pPr>
-            <a:fld id="{81D60167-4931-47E6-BA6A-407CBD079E47}" type="slidenum">
-              <a:rPr kern="0" spc="-33" dirty="0"/>
-              <a:pPr marL="50799" defTabSz="1219170">
-                <a:lnSpc>
-                  <a:spcPts val="2193"/>
-                </a:lnSpc>
-              </a:pPr>
-              <a:t>5</a:t>
-            </a:fld>
-            <a:endParaRPr kern="0" spc="-33" dirty="0"/>
-          </a:p>
-        </p:txBody>
-      </p:sp>
-    </p:spTree>
-    <p:custDataLst>
-      <p:tags r:id="rId1"/>
-    </p:custDataLst>
-  </p:cSld>
-  <p:clrMapOvr>
-    <a:masterClrMapping/>
-  </p:clrMapOvr>
-</p:sld>
-</file>
-
-<file path=ppt/slides/slide6.xml><?xml version="1.0" encoding="utf-8"?>
-<p:sld xmlns:a="http://schemas.openxmlformats.org/drawingml/2006/main" xmlns:r="http://schemas.openxmlformats.org/officeDocument/2006/relationships" xmlns:p="http://schemas.openxmlformats.org/presentationml/2006/main" showMasterSp="0">
-  <p:cSld>
-    <p:spTree>
-      <p:nvGrpSpPr>
-        <p:cNvPr id="1" name=""/>
-        <p:cNvGrpSpPr/>
-        <p:nvPr/>
-      </p:nvGrpSpPr>
-      <p:grpSpPr>
-        <a:xfrm>
-          <a:off x="0" y="0"/>
-          <a:ext cx="0" cy="0"/>
-          <a:chOff x="0" y="0"/>
-          <a:chExt cx="0" cy="0"/>
-        </a:xfrm>
-      </p:grpSpPr>
-      <p:sp>
-        <p:nvSpPr>
-          <p:cNvPr id="2" name="object 2"/>
-          <p:cNvSpPr txBox="1"/>
-          <p:nvPr/>
-        </p:nvSpPr>
-        <p:spPr>
-          <a:xfrm>
-            <a:off x="2230487" y="2636519"/>
-            <a:ext cx="3136900" cy="359073"/>
-          </a:xfrm>
-          <a:prstGeom prst="rect">
-            <a:avLst/>
-          </a:prstGeom>
-          <a:solidFill>
-            <a:srgbClr val="FFFF00"/>
-          </a:solidFill>
-        </p:spPr>
-        <p:txBody>
-          <a:bodyPr vert="horz" wrap="square" lIns="0" tIns="0" rIns="0" bIns="0" rtlCol="0">
-            <a:spAutoFit/>
-          </a:bodyPr>
-          <a:lstStyle/>
-          <a:p>
-            <a:pPr defTabSz="1219170">
-              <a:lnSpc>
-                <a:spcPts val="2787"/>
-              </a:lnSpc>
-            </a:pPr>
-            <a:r>
-              <a:rPr sz="2400" kern="0" dirty="0">
-                <a:solidFill>
-                  <a:srgbClr val="434343"/>
-                </a:solidFill>
-                <a:latin typeface="Roboto"/>
-                <a:cs typeface="Roboto"/>
-              </a:rPr>
-              <a:t>FCCID</a:t>
-            </a:r>
-            <a:r>
-              <a:rPr sz="2400" kern="0" spc="-53" dirty="0">
-                <a:solidFill>
-                  <a:srgbClr val="434343"/>
-                </a:solidFill>
-                <a:latin typeface="Roboto"/>
-                <a:cs typeface="Roboto"/>
-              </a:rPr>
-              <a:t> </a:t>
-            </a:r>
-            <a:r>
-              <a:rPr sz="2400" kern="0" dirty="0">
-                <a:solidFill>
-                  <a:srgbClr val="434343"/>
-                </a:solidFill>
-                <a:latin typeface="Roboto"/>
-                <a:cs typeface="Roboto"/>
-              </a:rPr>
-              <a:t>[ID</a:t>
-            </a:r>
-            <a:r>
-              <a:rPr sz="2400" kern="0" spc="-47" dirty="0">
-                <a:solidFill>
-                  <a:srgbClr val="434343"/>
-                </a:solidFill>
-                <a:latin typeface="Roboto"/>
-                <a:cs typeface="Roboto"/>
-              </a:rPr>
-              <a:t> </a:t>
-            </a:r>
-            <a:r>
-              <a:rPr sz="2400" kern="0" dirty="0">
-                <a:solidFill>
-                  <a:srgbClr val="434343"/>
-                </a:solidFill>
-                <a:latin typeface="Roboto"/>
-                <a:cs typeface="Roboto"/>
-              </a:rPr>
-              <a:t>ON</a:t>
-            </a:r>
-            <a:r>
-              <a:rPr sz="2400" kern="0" spc="-47" dirty="0">
-                <a:solidFill>
-                  <a:srgbClr val="434343"/>
-                </a:solidFill>
-                <a:latin typeface="Roboto"/>
-                <a:cs typeface="Roboto"/>
-              </a:rPr>
-              <a:t> </a:t>
-            </a:r>
-            <a:r>
-              <a:rPr sz="2400" kern="0" dirty="0">
-                <a:solidFill>
-                  <a:srgbClr val="434343"/>
-                </a:solidFill>
-                <a:latin typeface="Roboto"/>
-                <a:cs typeface="Roboto"/>
-              </a:rPr>
-              <a:t>KEY</a:t>
-            </a:r>
-            <a:r>
-              <a:rPr sz="2400" kern="0" spc="-47" dirty="0">
-                <a:solidFill>
-                  <a:srgbClr val="434343"/>
-                </a:solidFill>
-                <a:latin typeface="Roboto"/>
-                <a:cs typeface="Roboto"/>
-              </a:rPr>
-              <a:t> </a:t>
-            </a:r>
-            <a:r>
-              <a:rPr sz="2400" kern="0" spc="-27" dirty="0">
-                <a:solidFill>
-                  <a:srgbClr val="434343"/>
-                </a:solidFill>
-                <a:latin typeface="Roboto"/>
-                <a:cs typeface="Roboto"/>
-              </a:rPr>
-              <a:t>FOB]</a:t>
-            </a:r>
-            <a:endParaRPr sz="2400" kern="0">
-              <a:solidFill>
-                <a:sysClr val="windowText" lastClr="000000"/>
-              </a:solidFill>
-              <a:latin typeface="Roboto"/>
-              <a:cs typeface="Roboto"/>
-            </a:endParaRPr>
-          </a:p>
-        </p:txBody>
-      </p:sp>
-      <p:sp>
-        <p:nvSpPr>
-          <p:cNvPr id="3" name="object 3"/>
-          <p:cNvSpPr txBox="1"/>
-          <p:nvPr/>
-        </p:nvSpPr>
-        <p:spPr>
-          <a:xfrm>
-            <a:off x="646095" y="1875874"/>
-            <a:ext cx="6189980" cy="1494426"/>
-          </a:xfrm>
-          <a:prstGeom prst="rect">
-            <a:avLst/>
-          </a:prstGeom>
-        </p:spPr>
-        <p:txBody>
-          <a:bodyPr vert="horz" wrap="square" lIns="0" tIns="16933" rIns="0" bIns="0" rtlCol="0">
-            <a:spAutoFit/>
-          </a:bodyPr>
-          <a:lstStyle/>
-          <a:p>
-            <a:pPr marL="572331" indent="-555398" defTabSz="1219170">
-              <a:spcBef>
-                <a:spcPts val="133"/>
-              </a:spcBef>
-              <a:buFontTx/>
-              <a:buAutoNum type="arabicPeriod"/>
-              <a:tabLst>
-                <a:tab pos="572331" algn="l"/>
-              </a:tabLst>
-            </a:pPr>
-            <a:r>
-              <a:rPr sz="2400" kern="0" spc="-27" dirty="0">
-                <a:solidFill>
-                  <a:srgbClr val="434343"/>
-                </a:solidFill>
-                <a:latin typeface="Roboto"/>
-                <a:cs typeface="Roboto"/>
-              </a:rPr>
-              <a:t>Take</a:t>
-            </a:r>
-            <a:r>
-              <a:rPr sz="2400" kern="0" spc="-47" dirty="0">
-                <a:solidFill>
-                  <a:srgbClr val="434343"/>
-                </a:solidFill>
-                <a:latin typeface="Roboto"/>
-                <a:cs typeface="Roboto"/>
-              </a:rPr>
-              <a:t> </a:t>
-            </a:r>
-            <a:r>
-              <a:rPr sz="2400" kern="0" dirty="0">
-                <a:solidFill>
-                  <a:srgbClr val="434343"/>
-                </a:solidFill>
-                <a:latin typeface="Roboto"/>
-                <a:cs typeface="Roboto"/>
-              </a:rPr>
-              <a:t>a</a:t>
-            </a:r>
-            <a:r>
-              <a:rPr sz="2400" kern="0" spc="-40" dirty="0">
-                <a:solidFill>
-                  <a:srgbClr val="434343"/>
-                </a:solidFill>
-                <a:latin typeface="Roboto"/>
-                <a:cs typeface="Roboto"/>
-              </a:rPr>
-              <a:t> </a:t>
-            </a:r>
-            <a:r>
-              <a:rPr sz="2400" kern="0" dirty="0">
-                <a:solidFill>
-                  <a:srgbClr val="434343"/>
-                </a:solidFill>
-                <a:latin typeface="Roboto"/>
-                <a:cs typeface="Roboto"/>
-              </a:rPr>
-              <a:t>key</a:t>
-            </a:r>
-            <a:r>
-              <a:rPr sz="2400" kern="0" spc="-40" dirty="0">
-                <a:solidFill>
-                  <a:srgbClr val="434343"/>
-                </a:solidFill>
-                <a:latin typeface="Roboto"/>
-                <a:cs typeface="Roboto"/>
-              </a:rPr>
-              <a:t> </a:t>
-            </a:r>
-            <a:r>
-              <a:rPr sz="2400" kern="0" dirty="0">
-                <a:solidFill>
-                  <a:srgbClr val="434343"/>
-                </a:solidFill>
-                <a:latin typeface="Roboto"/>
-                <a:cs typeface="Roboto"/>
-              </a:rPr>
-              <a:t>fob</a:t>
-            </a:r>
-            <a:r>
-              <a:rPr sz="2400" kern="0" spc="-47" dirty="0">
-                <a:solidFill>
-                  <a:srgbClr val="434343"/>
-                </a:solidFill>
-                <a:latin typeface="Roboto"/>
-                <a:cs typeface="Roboto"/>
-              </a:rPr>
-              <a:t> </a:t>
-            </a:r>
-            <a:r>
-              <a:rPr sz="2400" kern="0" dirty="0">
-                <a:solidFill>
-                  <a:srgbClr val="434343"/>
-                </a:solidFill>
-                <a:latin typeface="Roboto"/>
-                <a:cs typeface="Roboto"/>
-              </a:rPr>
-              <a:t>/</a:t>
-            </a:r>
-            <a:r>
-              <a:rPr sz="2400" kern="0" spc="-40" dirty="0">
-                <a:solidFill>
-                  <a:srgbClr val="434343"/>
-                </a:solidFill>
-                <a:latin typeface="Roboto"/>
-                <a:cs typeface="Roboto"/>
-              </a:rPr>
-              <a:t> </a:t>
-            </a:r>
-            <a:r>
-              <a:rPr sz="2400" kern="0" dirty="0">
-                <a:solidFill>
-                  <a:srgbClr val="434343"/>
-                </a:solidFill>
-                <a:latin typeface="Roboto"/>
-                <a:cs typeface="Roboto"/>
-              </a:rPr>
-              <a:t>Use</a:t>
-            </a:r>
-            <a:r>
-              <a:rPr sz="2400" kern="0" spc="-40" dirty="0">
-                <a:solidFill>
-                  <a:srgbClr val="434343"/>
-                </a:solidFill>
-                <a:latin typeface="Roboto"/>
-                <a:cs typeface="Roboto"/>
-              </a:rPr>
-              <a:t> </a:t>
-            </a:r>
-            <a:r>
-              <a:rPr sz="2400" kern="0" dirty="0">
-                <a:solidFill>
-                  <a:srgbClr val="434343"/>
-                </a:solidFill>
-                <a:latin typeface="Roboto"/>
-                <a:cs typeface="Roboto"/>
-              </a:rPr>
-              <a:t>your</a:t>
-            </a:r>
-            <a:r>
-              <a:rPr sz="2400" kern="0" spc="-47" dirty="0">
-                <a:solidFill>
-                  <a:srgbClr val="434343"/>
-                </a:solidFill>
-                <a:latin typeface="Roboto"/>
-                <a:cs typeface="Roboto"/>
-              </a:rPr>
-              <a:t> </a:t>
-            </a:r>
-            <a:r>
-              <a:rPr sz="2400" kern="0" dirty="0">
-                <a:solidFill>
-                  <a:srgbClr val="434343"/>
-                </a:solidFill>
-                <a:latin typeface="Roboto"/>
-                <a:cs typeface="Roboto"/>
-              </a:rPr>
-              <a:t>own</a:t>
-            </a:r>
-            <a:r>
-              <a:rPr sz="2400" kern="0" spc="-40" dirty="0">
-                <a:solidFill>
-                  <a:srgbClr val="434343"/>
-                </a:solidFill>
-                <a:latin typeface="Roboto"/>
-                <a:cs typeface="Roboto"/>
-              </a:rPr>
-              <a:t> </a:t>
-            </a:r>
-            <a:r>
-              <a:rPr sz="2400" kern="0" dirty="0">
-                <a:solidFill>
-                  <a:srgbClr val="434343"/>
-                </a:solidFill>
-                <a:latin typeface="Roboto"/>
-                <a:cs typeface="Roboto"/>
-              </a:rPr>
-              <a:t>key</a:t>
-            </a:r>
-            <a:r>
-              <a:rPr sz="2400" kern="0" spc="-40" dirty="0">
-                <a:solidFill>
-                  <a:srgbClr val="434343"/>
-                </a:solidFill>
-                <a:latin typeface="Roboto"/>
-                <a:cs typeface="Roboto"/>
-              </a:rPr>
-              <a:t> </a:t>
-            </a:r>
-            <a:r>
-              <a:rPr sz="2400" kern="0" spc="-33" dirty="0">
-                <a:solidFill>
-                  <a:srgbClr val="434343"/>
-                </a:solidFill>
-                <a:latin typeface="Roboto"/>
-                <a:cs typeface="Roboto"/>
-              </a:rPr>
-              <a:t>fob</a:t>
-            </a:r>
-            <a:endParaRPr sz="2400" kern="0" dirty="0">
-              <a:solidFill>
-                <a:sysClr val="windowText" lastClr="000000"/>
-              </a:solidFill>
-              <a:latin typeface="Roboto"/>
-              <a:cs typeface="Roboto"/>
-            </a:endParaRPr>
-          </a:p>
-          <a:p>
-            <a:pPr marL="572331" indent="-555398" defTabSz="1219170">
-              <a:buFontTx/>
-              <a:buAutoNum type="arabicPeriod"/>
-              <a:tabLst>
-                <a:tab pos="572331" algn="l"/>
-              </a:tabLst>
-            </a:pPr>
-            <a:r>
-              <a:rPr sz="2400" kern="0" dirty="0">
-                <a:solidFill>
-                  <a:srgbClr val="434343"/>
-                </a:solidFill>
-                <a:latin typeface="Roboto"/>
-                <a:cs typeface="Roboto"/>
-              </a:rPr>
-              <a:t>Find</a:t>
-            </a:r>
-            <a:r>
-              <a:rPr sz="2400" kern="0" spc="-47" dirty="0">
-                <a:solidFill>
-                  <a:srgbClr val="434343"/>
-                </a:solidFill>
-                <a:latin typeface="Roboto"/>
-                <a:cs typeface="Roboto"/>
-              </a:rPr>
-              <a:t> </a:t>
-            </a:r>
-            <a:r>
-              <a:rPr sz="2400" kern="0" dirty="0">
-                <a:solidFill>
-                  <a:srgbClr val="434343"/>
-                </a:solidFill>
-                <a:latin typeface="Roboto"/>
-                <a:cs typeface="Roboto"/>
-              </a:rPr>
-              <a:t>the</a:t>
-            </a:r>
-            <a:r>
-              <a:rPr sz="2400" kern="0" spc="-40" dirty="0">
-                <a:solidFill>
-                  <a:srgbClr val="434343"/>
-                </a:solidFill>
-                <a:latin typeface="Roboto"/>
-                <a:cs typeface="Roboto"/>
-              </a:rPr>
-              <a:t> </a:t>
-            </a:r>
-            <a:r>
-              <a:rPr sz="2400" kern="0" dirty="0">
-                <a:solidFill>
-                  <a:srgbClr val="434343"/>
-                </a:solidFill>
-                <a:latin typeface="Roboto"/>
-                <a:cs typeface="Roboto"/>
-              </a:rPr>
-              <a:t>FCCID</a:t>
-            </a:r>
-            <a:r>
-              <a:rPr sz="2400" kern="0" spc="-40" dirty="0">
-                <a:solidFill>
-                  <a:srgbClr val="434343"/>
-                </a:solidFill>
-                <a:latin typeface="Roboto"/>
-                <a:cs typeface="Roboto"/>
-              </a:rPr>
-              <a:t> </a:t>
-            </a:r>
-            <a:r>
-              <a:rPr sz="2400" kern="0" dirty="0">
-                <a:solidFill>
-                  <a:srgbClr val="434343"/>
-                </a:solidFill>
-                <a:latin typeface="Roboto"/>
-                <a:cs typeface="Roboto"/>
-              </a:rPr>
-              <a:t>on</a:t>
-            </a:r>
-            <a:r>
-              <a:rPr sz="2400" kern="0" spc="-40" dirty="0">
-                <a:solidFill>
-                  <a:srgbClr val="434343"/>
-                </a:solidFill>
-                <a:latin typeface="Roboto"/>
-                <a:cs typeface="Roboto"/>
-              </a:rPr>
-              <a:t> </a:t>
-            </a:r>
-            <a:r>
-              <a:rPr sz="2400" kern="0" dirty="0">
-                <a:solidFill>
-                  <a:srgbClr val="434343"/>
-                </a:solidFill>
-                <a:latin typeface="Roboto"/>
-                <a:cs typeface="Roboto"/>
-              </a:rPr>
-              <a:t>the</a:t>
-            </a:r>
-            <a:r>
-              <a:rPr sz="2400" kern="0" spc="-40" dirty="0">
-                <a:solidFill>
-                  <a:srgbClr val="434343"/>
-                </a:solidFill>
-                <a:latin typeface="Roboto"/>
-                <a:cs typeface="Roboto"/>
-              </a:rPr>
-              <a:t> </a:t>
-            </a:r>
-            <a:r>
-              <a:rPr sz="2400" kern="0" dirty="0">
-                <a:solidFill>
-                  <a:srgbClr val="434343"/>
-                </a:solidFill>
-                <a:latin typeface="Roboto"/>
-                <a:cs typeface="Roboto"/>
-              </a:rPr>
-              <a:t>key</a:t>
-            </a:r>
-            <a:r>
-              <a:rPr sz="2400" kern="0" spc="-40" dirty="0">
-                <a:solidFill>
-                  <a:srgbClr val="434343"/>
-                </a:solidFill>
-                <a:latin typeface="Roboto"/>
-                <a:cs typeface="Roboto"/>
-              </a:rPr>
-              <a:t> </a:t>
-            </a:r>
-            <a:r>
-              <a:rPr sz="2400" kern="0" spc="-33" dirty="0">
-                <a:solidFill>
-                  <a:srgbClr val="434343"/>
-                </a:solidFill>
-                <a:latin typeface="Roboto"/>
-                <a:cs typeface="Roboto"/>
-              </a:rPr>
-              <a:t>fob</a:t>
-            </a:r>
-            <a:endParaRPr sz="2400" kern="0" dirty="0">
-              <a:solidFill>
-                <a:sysClr val="windowText" lastClr="000000"/>
-              </a:solidFill>
-              <a:latin typeface="Roboto"/>
-              <a:cs typeface="Roboto"/>
-            </a:endParaRPr>
-          </a:p>
-          <a:p>
-            <a:pPr marL="572331" indent="-555398" defTabSz="1219170">
-              <a:buFontTx/>
-              <a:buAutoNum type="arabicPeriod"/>
-              <a:tabLst>
-                <a:tab pos="572331" algn="l"/>
-                <a:tab pos="4795400" algn="l"/>
-              </a:tabLst>
-            </a:pPr>
-            <a:r>
-              <a:rPr sz="2400" kern="0" spc="-13" dirty="0">
-                <a:solidFill>
-                  <a:srgbClr val="434343"/>
-                </a:solidFill>
-                <a:latin typeface="Roboto"/>
-                <a:cs typeface="Roboto"/>
-              </a:rPr>
-              <a:t>Search</a:t>
-            </a:r>
-            <a:r>
-              <a:rPr lang="en-US" sz="2400" kern="0" dirty="0">
-                <a:solidFill>
-                  <a:srgbClr val="434343"/>
-                </a:solidFill>
-                <a:latin typeface="Roboto"/>
-                <a:cs typeface="Roboto"/>
-              </a:rPr>
-              <a:t>	</a:t>
-            </a:r>
-            <a:r>
-              <a:rPr sz="2400" kern="0" dirty="0">
-                <a:solidFill>
-                  <a:srgbClr val="434343"/>
-                </a:solidFill>
-                <a:latin typeface="Roboto"/>
-                <a:cs typeface="Roboto"/>
-              </a:rPr>
-              <a:t>on</a:t>
-            </a:r>
-            <a:r>
-              <a:rPr sz="2400" kern="0" spc="-27" dirty="0">
-                <a:solidFill>
-                  <a:srgbClr val="434343"/>
-                </a:solidFill>
-                <a:latin typeface="Roboto"/>
-                <a:cs typeface="Roboto"/>
-              </a:rPr>
-              <a:t> </a:t>
-            </a:r>
-            <a:r>
-              <a:rPr sz="2400" kern="0" spc="-13" dirty="0">
-                <a:solidFill>
-                  <a:srgbClr val="434343"/>
-                </a:solidFill>
-                <a:latin typeface="Roboto"/>
-                <a:cs typeface="Roboto"/>
-              </a:rPr>
-              <a:t>Google</a:t>
-            </a:r>
-            <a:endParaRPr lang="en-US" sz="2400" kern="0" spc="-13" dirty="0">
-              <a:solidFill>
-                <a:srgbClr val="434343"/>
-              </a:solidFill>
-              <a:latin typeface="Roboto"/>
-              <a:cs typeface="Roboto"/>
-            </a:endParaRPr>
-          </a:p>
-          <a:p>
-            <a:pPr marL="572331" indent="-555398" defTabSz="1219170">
-              <a:buFontTx/>
-              <a:buAutoNum type="arabicPeriod"/>
-              <a:tabLst>
-                <a:tab pos="572331" algn="l"/>
-                <a:tab pos="4795400" algn="l"/>
-              </a:tabLst>
-            </a:pPr>
-            <a:r>
-              <a:rPr lang="en-US" sz="2400" kern="0" dirty="0">
-                <a:solidFill>
-                  <a:sysClr val="windowText" lastClr="000000"/>
-                </a:solidFill>
-                <a:latin typeface="Roboto"/>
-                <a:cs typeface="Roboto"/>
-              </a:rPr>
-              <a:t>https://www.fcc.gov/oet/ea/fccid</a:t>
-            </a:r>
-            <a:endParaRPr sz="2400" kern="0" dirty="0">
-              <a:solidFill>
-                <a:sysClr val="windowText" lastClr="000000"/>
-              </a:solidFill>
-              <a:latin typeface="Roboto"/>
-              <a:cs typeface="Roboto"/>
-            </a:endParaRPr>
-          </a:p>
-        </p:txBody>
-      </p:sp>
-      <p:sp>
-        <p:nvSpPr>
-          <p:cNvPr id="4" name="object 4"/>
-          <p:cNvSpPr txBox="1"/>
-          <p:nvPr/>
-        </p:nvSpPr>
-        <p:spPr>
-          <a:xfrm>
-            <a:off x="604886" y="3743960"/>
-            <a:ext cx="6833447" cy="427532"/>
-          </a:xfrm>
-          <a:prstGeom prst="rect">
-            <a:avLst/>
-          </a:prstGeom>
-        </p:spPr>
-        <p:txBody>
-          <a:bodyPr vert="horz" wrap="square" lIns="0" tIns="16933" rIns="0" bIns="0" rtlCol="0">
-            <a:spAutoFit/>
-          </a:bodyPr>
-          <a:lstStyle/>
-          <a:p>
-            <a:pPr marL="16933" defTabSz="1219170">
-              <a:spcBef>
-                <a:spcPts val="133"/>
-              </a:spcBef>
-              <a:tabLst>
-                <a:tab pos="613818" algn="l"/>
-              </a:tabLst>
-            </a:pPr>
-            <a:r>
-              <a:rPr sz="2667" b="1" kern="0" spc="-33" dirty="0">
-                <a:solidFill>
-                  <a:srgbClr val="D13368"/>
-                </a:solidFill>
-                <a:latin typeface="Roboto"/>
-                <a:cs typeface="Roboto"/>
-              </a:rPr>
-              <a:t>4.</a:t>
-            </a:r>
-            <a:r>
-              <a:rPr sz="2667" b="1" kern="0" dirty="0">
-                <a:solidFill>
-                  <a:srgbClr val="D13368"/>
-                </a:solidFill>
-                <a:latin typeface="Roboto"/>
-                <a:cs typeface="Roboto"/>
-              </a:rPr>
-              <a:t>	What</a:t>
-            </a:r>
-            <a:r>
-              <a:rPr sz="2667" b="1" kern="0" spc="-53" dirty="0">
-                <a:solidFill>
-                  <a:srgbClr val="D13368"/>
-                </a:solidFill>
-                <a:latin typeface="Roboto"/>
-                <a:cs typeface="Roboto"/>
-              </a:rPr>
-              <a:t> </a:t>
-            </a:r>
-            <a:r>
-              <a:rPr sz="2667" b="1" kern="0" dirty="0">
-                <a:solidFill>
-                  <a:srgbClr val="D13368"/>
-                </a:solidFill>
-                <a:latin typeface="Roboto"/>
-                <a:cs typeface="Roboto"/>
-              </a:rPr>
-              <a:t>frequency</a:t>
-            </a:r>
-            <a:r>
-              <a:rPr sz="2667" b="1" kern="0" spc="-47" dirty="0">
-                <a:solidFill>
-                  <a:srgbClr val="D13368"/>
-                </a:solidFill>
-                <a:latin typeface="Roboto"/>
-                <a:cs typeface="Roboto"/>
-              </a:rPr>
-              <a:t> </a:t>
-            </a:r>
-            <a:r>
-              <a:rPr sz="2667" b="1" kern="0" dirty="0">
-                <a:solidFill>
-                  <a:srgbClr val="D13368"/>
-                </a:solidFill>
-                <a:latin typeface="Roboto"/>
-                <a:cs typeface="Roboto"/>
-              </a:rPr>
-              <a:t>does</a:t>
-            </a:r>
-            <a:r>
-              <a:rPr sz="2667" b="1" kern="0" spc="-53" dirty="0">
-                <a:solidFill>
-                  <a:srgbClr val="D13368"/>
-                </a:solidFill>
-                <a:latin typeface="Roboto"/>
-                <a:cs typeface="Roboto"/>
-              </a:rPr>
-              <a:t> </a:t>
-            </a:r>
-            <a:r>
-              <a:rPr sz="2667" b="1" kern="0" dirty="0">
-                <a:solidFill>
-                  <a:srgbClr val="D13368"/>
-                </a:solidFill>
-                <a:latin typeface="Roboto"/>
-                <a:cs typeface="Roboto"/>
-              </a:rPr>
-              <a:t>the</a:t>
-            </a:r>
-            <a:r>
-              <a:rPr sz="2667" b="1" kern="0" spc="-47" dirty="0">
-                <a:solidFill>
-                  <a:srgbClr val="D13368"/>
-                </a:solidFill>
-                <a:latin typeface="Roboto"/>
-                <a:cs typeface="Roboto"/>
-              </a:rPr>
-              <a:t> </a:t>
-            </a:r>
-            <a:r>
-              <a:rPr sz="2667" b="1" kern="0" dirty="0">
-                <a:solidFill>
-                  <a:srgbClr val="D13368"/>
-                </a:solidFill>
-                <a:latin typeface="Roboto"/>
-                <a:cs typeface="Roboto"/>
-              </a:rPr>
-              <a:t>key</a:t>
-            </a:r>
-            <a:r>
-              <a:rPr sz="2667" b="1" kern="0" spc="-53" dirty="0">
-                <a:solidFill>
-                  <a:srgbClr val="D13368"/>
-                </a:solidFill>
-                <a:latin typeface="Roboto"/>
-                <a:cs typeface="Roboto"/>
-              </a:rPr>
-              <a:t> </a:t>
-            </a:r>
-            <a:r>
-              <a:rPr sz="2667" b="1" kern="0" dirty="0">
-                <a:solidFill>
-                  <a:srgbClr val="D13368"/>
-                </a:solidFill>
-                <a:latin typeface="Roboto"/>
-                <a:cs typeface="Roboto"/>
-              </a:rPr>
-              <a:t>fob</a:t>
-            </a:r>
-            <a:r>
-              <a:rPr sz="2667" b="1" kern="0" spc="-47" dirty="0">
-                <a:solidFill>
-                  <a:srgbClr val="D13368"/>
-                </a:solidFill>
-                <a:latin typeface="Roboto"/>
-                <a:cs typeface="Roboto"/>
-              </a:rPr>
-              <a:t> </a:t>
-            </a:r>
-            <a:r>
-              <a:rPr sz="2667" b="1" kern="0" dirty="0">
-                <a:solidFill>
-                  <a:srgbClr val="D13368"/>
-                </a:solidFill>
-                <a:latin typeface="Roboto"/>
-                <a:cs typeface="Roboto"/>
-              </a:rPr>
-              <a:t>run</a:t>
-            </a:r>
-            <a:r>
-              <a:rPr sz="2667" b="1" kern="0" spc="-53" dirty="0">
-                <a:solidFill>
-                  <a:srgbClr val="D13368"/>
-                </a:solidFill>
-                <a:latin typeface="Roboto"/>
-                <a:cs typeface="Roboto"/>
-              </a:rPr>
-              <a:t> </a:t>
-            </a:r>
-            <a:r>
-              <a:rPr sz="2667" b="1" kern="0" spc="-33" dirty="0">
-                <a:solidFill>
-                  <a:srgbClr val="D13368"/>
-                </a:solidFill>
-                <a:latin typeface="Roboto"/>
-                <a:cs typeface="Roboto"/>
-              </a:rPr>
-              <a:t>on?</a:t>
-            </a:r>
-            <a:endParaRPr sz="2667" kern="0">
-              <a:solidFill>
-                <a:sysClr val="windowText" lastClr="000000"/>
-              </a:solidFill>
-              <a:latin typeface="Roboto"/>
-              <a:cs typeface="Roboto"/>
-            </a:endParaRPr>
-          </a:p>
-        </p:txBody>
-      </p:sp>
-      <p:sp>
-        <p:nvSpPr>
-          <p:cNvPr id="7" name="object 7"/>
-          <p:cNvSpPr txBox="1">
-            <a:spLocks noGrp="1"/>
-          </p:cNvSpPr>
-          <p:nvPr>
-            <p:ph type="sldNum" sz="quarter" idx="12"/>
-          </p:nvPr>
-        </p:nvSpPr>
-        <p:spPr>
-          <a:prstGeom prst="rect">
-            <a:avLst/>
-          </a:prstGeom>
-        </p:spPr>
-        <p:txBody>
-          <a:bodyPr vert="horz" wrap="square" lIns="0" tIns="0" rIns="0" bIns="0" rtlCol="0">
-            <a:spAutoFit/>
-          </a:bodyPr>
-          <a:lstStyle/>
-          <a:p>
-            <a:pPr marL="50799" defTabSz="1219170">
-              <a:lnSpc>
-                <a:spcPts val="2193"/>
-              </a:lnSpc>
-            </a:pPr>
-            <a:fld id="{81D60167-4931-47E6-BA6A-407CBD079E47}" type="slidenum">
-              <a:rPr kern="0" spc="-33" dirty="0"/>
-              <a:pPr marL="50799" defTabSz="1219170">
-                <a:lnSpc>
-                  <a:spcPts val="2193"/>
-                </a:lnSpc>
-              </a:pPr>
-              <a:t>6</a:t>
-            </a:fld>
-            <a:endParaRPr kern="0" spc="-33" dirty="0"/>
-          </a:p>
-        </p:txBody>
-      </p:sp>
-      <p:sp>
-        <p:nvSpPr>
-          <p:cNvPr id="5" name="object 5" descr="$PPTXTitle"/>
-          <p:cNvSpPr txBox="1">
-            <a:spLocks noGrp="1"/>
-          </p:cNvSpPr>
-          <p:nvPr>
-            <p:ph type="title" idx="4294967295"/>
-          </p:nvPr>
-        </p:nvSpPr>
-        <p:spPr>
-          <a:xfrm>
-            <a:off x="0" y="557213"/>
-            <a:ext cx="6330950" cy="631825"/>
-          </a:xfrm>
-          <a:prstGeom prst="rect">
-            <a:avLst/>
-          </a:prstGeom>
-        </p:spPr>
-        <p:txBody>
-          <a:bodyPr vert="horz" wrap="square" lIns="0" tIns="16933" rIns="0" bIns="0" rtlCol="0">
-            <a:spAutoFit/>
-          </a:bodyPr>
-          <a:lstStyle/>
-          <a:p>
-            <a:pPr marL="16933">
-              <a:spcBef>
-                <a:spcPts val="133"/>
-              </a:spcBef>
-            </a:pPr>
-            <a:r>
-              <a:rPr dirty="0"/>
-              <a:t>FCCID</a:t>
-            </a:r>
-            <a:r>
-              <a:rPr spc="-80" dirty="0"/>
-              <a:t> </a:t>
-            </a:r>
-            <a:r>
-              <a:rPr dirty="0"/>
-              <a:t>Lookup</a:t>
-            </a:r>
-            <a:r>
-              <a:rPr spc="-60" dirty="0"/>
-              <a:t> </a:t>
-            </a:r>
-            <a:r>
-              <a:rPr dirty="0">
-                <a:solidFill>
-                  <a:srgbClr val="2A3890"/>
-                </a:solidFill>
-              </a:rPr>
-              <a:t>–</a:t>
-            </a:r>
-            <a:r>
-              <a:rPr spc="-80" dirty="0">
-                <a:solidFill>
-                  <a:srgbClr val="2A3890"/>
-                </a:solidFill>
-              </a:rPr>
-              <a:t> </a:t>
-            </a:r>
-            <a:r>
-              <a:rPr spc="-13" dirty="0">
-                <a:solidFill>
-                  <a:srgbClr val="2A3890"/>
-                </a:solidFill>
-              </a:rPr>
-              <a:t>Exercise</a:t>
-            </a:r>
-          </a:p>
-        </p:txBody>
-      </p:sp>
-      <p:pic>
-        <p:nvPicPr>
-          <p:cNvPr id="6" name="object 6"/>
-          <p:cNvPicPr/>
-          <p:nvPr/>
-        </p:nvPicPr>
-        <p:blipFill>
-          <a:blip r:embed="rId3" cstate="email">
-            <a:extLst>
-              <a:ext uri="{28A0092B-C50C-407E-A947-70E740481C1C}">
-                <a14:useLocalDpi xmlns:a14="http://schemas.microsoft.com/office/drawing/2010/main"/>
-              </a:ext>
-            </a:extLst>
-          </a:blip>
-          <a:stretch>
-            <a:fillRect/>
-          </a:stretch>
-        </p:blipFill>
-        <p:spPr>
-          <a:xfrm>
-            <a:off x="8112132" y="814367"/>
-            <a:ext cx="3368832" cy="5692767"/>
-          </a:xfrm>
-          <a:prstGeom prst="rect">
-            <a:avLst/>
-          </a:prstGeom>
-        </p:spPr>
-      </p:pic>
-    </p:spTree>
-    <p:custDataLst>
-      <p:tags r:id="rId1"/>
-    </p:custDataLst>
-  </p:cSld>
-  <p:clrMapOvr>
-    <a:masterClrMapping/>
-  </p:clrMapOvr>
-</p:sld>
-</file>
-
-<file path=ppt/slides/slide7.xml><?xml version="1.0" encoding="utf-8"?>
-<p:sld xmlns:a="http://schemas.openxmlformats.org/drawingml/2006/main" xmlns:r="http://schemas.openxmlformats.org/officeDocument/2006/relationships" xmlns:p="http://schemas.openxmlformats.org/presentationml/2006/main" showMasterSp="0">
-  <p:cSld>
-    <p:spTree>
-      <p:nvGrpSpPr>
-        <p:cNvPr id="1" name=""/>
-        <p:cNvGrpSpPr/>
-        <p:nvPr/>
-      </p:nvGrpSpPr>
-      <p:grpSpPr>
-        <a:xfrm>
-          <a:off x="0" y="0"/>
-          <a:ext cx="0" cy="0"/>
-          <a:chOff x="0" y="0"/>
-          <a:chExt cx="0" cy="0"/>
-        </a:xfrm>
-      </p:grpSpPr>
-      <p:sp>
-        <p:nvSpPr>
-          <p:cNvPr id="2" name="object 2" descr="$PPTXTitle"/>
-          <p:cNvSpPr txBox="1">
-            <a:spLocks noGrp="1"/>
-          </p:cNvSpPr>
-          <p:nvPr>
-            <p:ph type="title" idx="4294967295"/>
-          </p:nvPr>
-        </p:nvSpPr>
-        <p:spPr>
-          <a:xfrm>
-            <a:off x="0" y="613363"/>
-            <a:ext cx="8370771" cy="631825"/>
-          </a:xfrm>
-          <a:prstGeom prst="rect">
-            <a:avLst/>
-          </a:prstGeom>
-        </p:spPr>
-        <p:txBody>
-          <a:bodyPr vert="horz" wrap="square" lIns="0" tIns="16933" rIns="0" bIns="0" rtlCol="0">
-            <a:spAutoFit/>
-          </a:bodyPr>
-          <a:lstStyle/>
-          <a:p>
-            <a:pPr marL="16933">
-              <a:spcBef>
-                <a:spcPts val="133"/>
-              </a:spcBef>
-            </a:pPr>
-            <a:r>
-              <a:rPr dirty="0"/>
-              <a:t>FCCID</a:t>
-            </a:r>
-            <a:r>
-              <a:rPr spc="-73" dirty="0"/>
-              <a:t> </a:t>
-            </a:r>
-            <a:r>
-              <a:rPr dirty="0"/>
-              <a:t>Lookup</a:t>
-            </a:r>
-            <a:r>
-              <a:rPr spc="-47" dirty="0"/>
-              <a:t> </a:t>
-            </a:r>
-            <a:r>
-              <a:rPr dirty="0">
-                <a:solidFill>
-                  <a:srgbClr val="2A3890"/>
-                </a:solidFill>
-              </a:rPr>
-              <a:t>–</a:t>
-            </a:r>
-            <a:r>
-              <a:rPr spc="-67" dirty="0">
-                <a:solidFill>
-                  <a:srgbClr val="2A3890"/>
-                </a:solidFill>
-              </a:rPr>
-              <a:t> </a:t>
-            </a:r>
-            <a:r>
-              <a:rPr dirty="0">
-                <a:solidFill>
-                  <a:srgbClr val="2A3890"/>
-                </a:solidFill>
-              </a:rPr>
-              <a:t>Other</a:t>
-            </a:r>
-            <a:r>
-              <a:rPr spc="-67" dirty="0">
-                <a:solidFill>
-                  <a:srgbClr val="2A3890"/>
-                </a:solidFill>
-              </a:rPr>
-              <a:t> </a:t>
-            </a:r>
-            <a:r>
-              <a:rPr spc="-13" dirty="0">
-                <a:solidFill>
-                  <a:srgbClr val="2A3890"/>
-                </a:solidFill>
-              </a:rPr>
-              <a:t>Examples</a:t>
-            </a:r>
-          </a:p>
-        </p:txBody>
-      </p:sp>
-      <p:grpSp>
-        <p:nvGrpSpPr>
-          <p:cNvPr id="3" name="object 3"/>
-          <p:cNvGrpSpPr/>
-          <p:nvPr/>
-        </p:nvGrpSpPr>
-        <p:grpSpPr>
-          <a:xfrm>
-            <a:off x="1341934" y="1509400"/>
-            <a:ext cx="3553460" cy="2198793"/>
-            <a:chOff x="1006450" y="1132049"/>
-            <a:chExt cx="2665095" cy="1649095"/>
-          </a:xfrm>
-        </p:grpSpPr>
-        <p:pic>
-          <p:nvPicPr>
-            <p:cNvPr id="4" name="object 4"/>
-            <p:cNvPicPr/>
-            <p:nvPr/>
-          </p:nvPicPr>
-          <p:blipFill>
-            <a:blip r:embed="rId3" cstate="email">
-              <a:extLst>
-                <a:ext uri="{28A0092B-C50C-407E-A947-70E740481C1C}">
-                  <a14:useLocalDpi xmlns:a14="http://schemas.microsoft.com/office/drawing/2010/main"/>
-                </a:ext>
-              </a:extLst>
-            </a:blip>
-            <a:stretch>
-              <a:fillRect/>
-            </a:stretch>
-          </p:blipFill>
-          <p:spPr>
-            <a:xfrm>
-              <a:off x="1015975" y="1141574"/>
-              <a:ext cx="2645450" cy="1629425"/>
-            </a:xfrm>
-            <a:prstGeom prst="rect">
-              <a:avLst/>
-            </a:prstGeom>
-          </p:spPr>
-        </p:pic>
-        <p:sp>
-          <p:nvSpPr>
-            <p:cNvPr id="5" name="object 5"/>
-            <p:cNvSpPr/>
-            <p:nvPr/>
-          </p:nvSpPr>
-          <p:spPr>
-            <a:xfrm>
-              <a:off x="1011212" y="1136812"/>
-              <a:ext cx="2655570" cy="1639570"/>
-            </a:xfrm>
-            <a:custGeom>
-              <a:avLst/>
-              <a:gdLst/>
-              <a:ahLst/>
-              <a:cxnLst/>
-              <a:rect l="l" t="t" r="r" b="b"/>
-              <a:pathLst>
-                <a:path w="2655570" h="1639570">
-                  <a:moveTo>
-                    <a:pt x="0" y="0"/>
-                  </a:moveTo>
-                  <a:lnTo>
-                    <a:pt x="2654975" y="0"/>
-                  </a:lnTo>
-                  <a:lnTo>
-                    <a:pt x="2654975" y="1638950"/>
-                  </a:lnTo>
-                  <a:lnTo>
-                    <a:pt x="0" y="1638950"/>
-                  </a:lnTo>
-                  <a:lnTo>
-                    <a:pt x="0" y="0"/>
-                  </a:lnTo>
-                  <a:close/>
-                </a:path>
-              </a:pathLst>
-            </a:custGeom>
-            <a:ln w="9524">
-              <a:solidFill>
-                <a:srgbClr val="434343"/>
-              </a:solidFill>
-            </a:ln>
-          </p:spPr>
-          <p:txBody>
-            <a:bodyPr wrap="square" lIns="0" tIns="0" rIns="0" bIns="0" rtlCol="0"/>
-            <a:lstStyle/>
-            <a:p>
-              <a:pPr defTabSz="1219170"/>
-              <a:endParaRPr sz="2400" kern="0">
-                <a:solidFill>
-                  <a:sysClr val="windowText" lastClr="000000"/>
-                </a:solidFill>
-              </a:endParaRPr>
-            </a:p>
-          </p:txBody>
-        </p:sp>
-      </p:grpSp>
-      <p:sp>
-        <p:nvSpPr>
-          <p:cNvPr id="6" name="object 6"/>
-          <p:cNvSpPr txBox="1"/>
-          <p:nvPr/>
-        </p:nvSpPr>
-        <p:spPr>
-          <a:xfrm>
-            <a:off x="2159102" y="3779841"/>
-            <a:ext cx="1916007" cy="386430"/>
-          </a:xfrm>
-          <a:prstGeom prst="rect">
-            <a:avLst/>
-          </a:prstGeom>
-        </p:spPr>
-        <p:txBody>
-          <a:bodyPr vert="horz" wrap="square" lIns="0" tIns="16933" rIns="0" bIns="0" rtlCol="0">
-            <a:spAutoFit/>
-          </a:bodyPr>
-          <a:lstStyle/>
-          <a:p>
-            <a:pPr marL="16933" defTabSz="1219170">
-              <a:spcBef>
-                <a:spcPts val="133"/>
-              </a:spcBef>
-            </a:pPr>
-            <a:r>
-              <a:rPr sz="2400" b="1" kern="0" dirty="0">
-                <a:solidFill>
-                  <a:srgbClr val="212D73"/>
-                </a:solidFill>
-                <a:latin typeface="Roboto"/>
-                <a:cs typeface="Roboto"/>
-              </a:rPr>
-              <a:t>iPhone</a:t>
-            </a:r>
-            <a:r>
-              <a:rPr sz="2400" b="1" kern="0" spc="-120" dirty="0">
-                <a:solidFill>
-                  <a:srgbClr val="212D73"/>
-                </a:solidFill>
-                <a:latin typeface="Roboto"/>
-                <a:cs typeface="Roboto"/>
-              </a:rPr>
-              <a:t> </a:t>
-            </a:r>
-            <a:r>
-              <a:rPr sz="2400" b="1" kern="0" spc="-13" dirty="0">
-                <a:solidFill>
-                  <a:srgbClr val="212D73"/>
-                </a:solidFill>
-                <a:latin typeface="Roboto"/>
-                <a:cs typeface="Roboto"/>
-              </a:rPr>
-              <a:t>FCCID</a:t>
-            </a:r>
-            <a:endParaRPr sz="2400" kern="0">
-              <a:solidFill>
-                <a:sysClr val="windowText" lastClr="000000"/>
-              </a:solidFill>
-              <a:latin typeface="Roboto"/>
-              <a:cs typeface="Roboto"/>
-            </a:endParaRPr>
-          </a:p>
-        </p:txBody>
-      </p:sp>
-      <p:grpSp>
-        <p:nvGrpSpPr>
-          <p:cNvPr id="7" name="object 7"/>
-          <p:cNvGrpSpPr/>
-          <p:nvPr/>
-        </p:nvGrpSpPr>
-        <p:grpSpPr>
-          <a:xfrm>
-            <a:off x="7028999" y="1509401"/>
-            <a:ext cx="4030133" cy="2198793"/>
-            <a:chOff x="5271749" y="1132050"/>
-            <a:chExt cx="3022600" cy="1649095"/>
-          </a:xfrm>
-        </p:grpSpPr>
-        <p:pic>
-          <p:nvPicPr>
-            <p:cNvPr id="8" name="object 8"/>
-            <p:cNvPicPr/>
-            <p:nvPr/>
-          </p:nvPicPr>
-          <p:blipFill>
-            <a:blip r:embed="rId4" cstate="email">
-              <a:extLst>
-                <a:ext uri="{28A0092B-C50C-407E-A947-70E740481C1C}">
-                  <a14:useLocalDpi xmlns:a14="http://schemas.microsoft.com/office/drawing/2010/main"/>
-                </a:ext>
-              </a:extLst>
-            </a:blip>
-            <a:stretch>
-              <a:fillRect/>
-            </a:stretch>
-          </p:blipFill>
-          <p:spPr>
-            <a:xfrm>
-              <a:off x="5281274" y="1141575"/>
-              <a:ext cx="3003418" cy="1629424"/>
-            </a:xfrm>
-            <a:prstGeom prst="rect">
-              <a:avLst/>
-            </a:prstGeom>
-          </p:spPr>
-        </p:pic>
-        <p:sp>
-          <p:nvSpPr>
-            <p:cNvPr id="9" name="object 9"/>
-            <p:cNvSpPr/>
-            <p:nvPr/>
-          </p:nvSpPr>
-          <p:spPr>
-            <a:xfrm>
-              <a:off x="5276512" y="1136812"/>
-              <a:ext cx="3013075" cy="1639570"/>
-            </a:xfrm>
-            <a:custGeom>
-              <a:avLst/>
-              <a:gdLst/>
-              <a:ahLst/>
-              <a:cxnLst/>
-              <a:rect l="l" t="t" r="r" b="b"/>
-              <a:pathLst>
-                <a:path w="3013075" h="1639570">
-                  <a:moveTo>
-                    <a:pt x="0" y="0"/>
-                  </a:moveTo>
-                  <a:lnTo>
-                    <a:pt x="3012943" y="0"/>
-                  </a:lnTo>
-                  <a:lnTo>
-                    <a:pt x="3012943" y="1638949"/>
-                  </a:lnTo>
-                  <a:lnTo>
-                    <a:pt x="0" y="1638949"/>
-                  </a:lnTo>
-                  <a:lnTo>
-                    <a:pt x="0" y="0"/>
-                  </a:lnTo>
-                  <a:close/>
-                </a:path>
-              </a:pathLst>
-            </a:custGeom>
-            <a:ln w="9524">
-              <a:solidFill>
-                <a:srgbClr val="434343"/>
-              </a:solidFill>
-            </a:ln>
-          </p:spPr>
-          <p:txBody>
-            <a:bodyPr wrap="square" lIns="0" tIns="0" rIns="0" bIns="0" rtlCol="0"/>
-            <a:lstStyle/>
-            <a:p>
-              <a:pPr defTabSz="1219170"/>
-              <a:endParaRPr sz="2400" kern="0">
-                <a:solidFill>
-                  <a:sysClr val="windowText" lastClr="000000"/>
-                </a:solidFill>
-              </a:endParaRPr>
-            </a:p>
-          </p:txBody>
-        </p:sp>
-      </p:grpSp>
-      <p:sp>
-        <p:nvSpPr>
-          <p:cNvPr id="10" name="object 10"/>
-          <p:cNvSpPr txBox="1"/>
-          <p:nvPr/>
-        </p:nvSpPr>
-        <p:spPr>
-          <a:xfrm>
-            <a:off x="8018145" y="3779841"/>
-            <a:ext cx="2049780" cy="386430"/>
-          </a:xfrm>
-          <a:prstGeom prst="rect">
-            <a:avLst/>
-          </a:prstGeom>
-        </p:spPr>
-        <p:txBody>
-          <a:bodyPr vert="horz" wrap="square" lIns="0" tIns="16933" rIns="0" bIns="0" rtlCol="0">
-            <a:spAutoFit/>
-          </a:bodyPr>
-          <a:lstStyle/>
-          <a:p>
-            <a:pPr marL="16933" defTabSz="1219170">
-              <a:spcBef>
-                <a:spcPts val="133"/>
-              </a:spcBef>
-            </a:pPr>
-            <a:r>
-              <a:rPr sz="2400" b="1" kern="0" dirty="0">
-                <a:solidFill>
-                  <a:srgbClr val="212D73"/>
-                </a:solidFill>
-                <a:latin typeface="Roboto"/>
-                <a:cs typeface="Roboto"/>
-              </a:rPr>
-              <a:t>Key</a:t>
-            </a:r>
-            <a:r>
-              <a:rPr sz="2400" b="1" kern="0" spc="-67" dirty="0">
-                <a:solidFill>
-                  <a:srgbClr val="212D73"/>
-                </a:solidFill>
-                <a:latin typeface="Roboto"/>
-                <a:cs typeface="Roboto"/>
-              </a:rPr>
-              <a:t> </a:t>
-            </a:r>
-            <a:r>
-              <a:rPr sz="2400" b="1" kern="0" dirty="0">
-                <a:solidFill>
-                  <a:srgbClr val="212D73"/>
-                </a:solidFill>
-                <a:latin typeface="Roboto"/>
-                <a:cs typeface="Roboto"/>
-              </a:rPr>
-              <a:t>Fob</a:t>
-            </a:r>
-            <a:r>
-              <a:rPr sz="2400" b="1" kern="0" spc="-60" dirty="0">
-                <a:solidFill>
-                  <a:srgbClr val="212D73"/>
-                </a:solidFill>
-                <a:latin typeface="Roboto"/>
-                <a:cs typeface="Roboto"/>
-              </a:rPr>
-              <a:t> </a:t>
-            </a:r>
-            <a:r>
-              <a:rPr sz="2400" b="1" kern="0" spc="-13" dirty="0">
-                <a:solidFill>
-                  <a:srgbClr val="212D73"/>
-                </a:solidFill>
-                <a:latin typeface="Roboto"/>
-                <a:cs typeface="Roboto"/>
-              </a:rPr>
-              <a:t>FCCID</a:t>
-            </a:r>
-            <a:endParaRPr sz="2400" kern="0">
-              <a:solidFill>
-                <a:sysClr val="windowText" lastClr="000000"/>
-              </a:solidFill>
-              <a:latin typeface="Roboto"/>
-              <a:cs typeface="Roboto"/>
-            </a:endParaRPr>
-          </a:p>
-        </p:txBody>
-      </p:sp>
-      <p:grpSp>
-        <p:nvGrpSpPr>
-          <p:cNvPr id="11" name="object 11"/>
-          <p:cNvGrpSpPr/>
-          <p:nvPr/>
-        </p:nvGrpSpPr>
-        <p:grpSpPr>
-          <a:xfrm>
-            <a:off x="4689667" y="4281966"/>
-            <a:ext cx="2786380" cy="1943100"/>
-            <a:chOff x="3517250" y="3211474"/>
-            <a:chExt cx="2089785" cy="1457325"/>
-          </a:xfrm>
-        </p:grpSpPr>
-        <p:pic>
-          <p:nvPicPr>
-            <p:cNvPr id="12" name="object 12"/>
-            <p:cNvPicPr/>
-            <p:nvPr/>
-          </p:nvPicPr>
-          <p:blipFill>
-            <a:blip r:embed="rId5" cstate="email">
-              <a:extLst>
-                <a:ext uri="{28A0092B-C50C-407E-A947-70E740481C1C}">
-                  <a14:useLocalDpi xmlns:a14="http://schemas.microsoft.com/office/drawing/2010/main"/>
-                </a:ext>
-              </a:extLst>
-            </a:blip>
-            <a:stretch>
-              <a:fillRect/>
-            </a:stretch>
-          </p:blipFill>
-          <p:spPr>
-            <a:xfrm>
-              <a:off x="3526775" y="3220999"/>
-              <a:ext cx="2070324" cy="1437749"/>
-            </a:xfrm>
-            <a:prstGeom prst="rect">
-              <a:avLst/>
-            </a:prstGeom>
-          </p:spPr>
-        </p:pic>
-        <p:sp>
-          <p:nvSpPr>
-            <p:cNvPr id="13" name="object 13"/>
-            <p:cNvSpPr/>
-            <p:nvPr/>
-          </p:nvSpPr>
-          <p:spPr>
-            <a:xfrm>
-              <a:off x="3522012" y="3216237"/>
-              <a:ext cx="2080260" cy="1447800"/>
-            </a:xfrm>
-            <a:custGeom>
-              <a:avLst/>
-              <a:gdLst/>
-              <a:ahLst/>
-              <a:cxnLst/>
-              <a:rect l="l" t="t" r="r" b="b"/>
-              <a:pathLst>
-                <a:path w="2080260" h="1447800">
-                  <a:moveTo>
-                    <a:pt x="0" y="0"/>
-                  </a:moveTo>
-                  <a:lnTo>
-                    <a:pt x="2079849" y="0"/>
-                  </a:lnTo>
-                  <a:lnTo>
-                    <a:pt x="2079849" y="1447274"/>
-                  </a:lnTo>
-                  <a:lnTo>
-                    <a:pt x="0" y="1447274"/>
-                  </a:lnTo>
-                  <a:lnTo>
-                    <a:pt x="0" y="0"/>
-                  </a:lnTo>
-                  <a:close/>
-                </a:path>
-              </a:pathLst>
-            </a:custGeom>
-            <a:ln w="9524">
-              <a:solidFill>
-                <a:srgbClr val="434343"/>
-              </a:solidFill>
-            </a:ln>
-          </p:spPr>
-          <p:txBody>
-            <a:bodyPr wrap="square" lIns="0" tIns="0" rIns="0" bIns="0" rtlCol="0"/>
-            <a:lstStyle/>
-            <a:p>
-              <a:pPr defTabSz="1219170"/>
-              <a:endParaRPr sz="2400" kern="0">
-                <a:solidFill>
-                  <a:sysClr val="windowText" lastClr="000000"/>
-                </a:solidFill>
-              </a:endParaRPr>
-            </a:p>
-          </p:txBody>
-        </p:sp>
-      </p:grpSp>
-      <p:sp>
-        <p:nvSpPr>
-          <p:cNvPr id="14" name="object 14"/>
-          <p:cNvSpPr txBox="1"/>
-          <p:nvPr/>
-        </p:nvSpPr>
-        <p:spPr>
-          <a:xfrm>
-            <a:off x="4603347" y="6318869"/>
-            <a:ext cx="2954867" cy="359073"/>
-          </a:xfrm>
-          <a:prstGeom prst="rect">
-            <a:avLst/>
-          </a:prstGeom>
-        </p:spPr>
-        <p:txBody>
-          <a:bodyPr vert="horz" wrap="square" lIns="0" tIns="0" rIns="0" bIns="0" rtlCol="0">
-            <a:spAutoFit/>
-          </a:bodyPr>
-          <a:lstStyle/>
-          <a:p>
-            <a:pPr marL="16933" defTabSz="1219170">
-              <a:lnSpc>
-                <a:spcPts val="2840"/>
-              </a:lnSpc>
-            </a:pPr>
-            <a:r>
-              <a:rPr sz="2400" b="1" kern="0" dirty="0">
-                <a:solidFill>
-                  <a:srgbClr val="212D73"/>
-                </a:solidFill>
-                <a:latin typeface="Roboto"/>
-                <a:cs typeface="Roboto"/>
-              </a:rPr>
-              <a:t>PS5</a:t>
-            </a:r>
-            <a:r>
-              <a:rPr sz="2400" b="1" kern="0" spc="-53" dirty="0">
-                <a:solidFill>
-                  <a:srgbClr val="212D73"/>
-                </a:solidFill>
-                <a:latin typeface="Roboto"/>
-                <a:cs typeface="Roboto"/>
-              </a:rPr>
-              <a:t> </a:t>
-            </a:r>
-            <a:r>
-              <a:rPr sz="2400" b="1" kern="0" spc="-13" dirty="0">
-                <a:solidFill>
-                  <a:srgbClr val="212D73"/>
-                </a:solidFill>
-                <a:latin typeface="Roboto"/>
-                <a:cs typeface="Roboto"/>
-              </a:rPr>
-              <a:t>Controller</a:t>
-            </a:r>
-            <a:r>
-              <a:rPr sz="2400" b="1" kern="0" spc="-47" dirty="0">
-                <a:solidFill>
-                  <a:srgbClr val="212D73"/>
-                </a:solidFill>
-                <a:latin typeface="Roboto"/>
-                <a:cs typeface="Roboto"/>
-              </a:rPr>
-              <a:t> </a:t>
-            </a:r>
-            <a:r>
-              <a:rPr sz="2400" b="1" kern="0" spc="-13" dirty="0">
-                <a:solidFill>
-                  <a:srgbClr val="212D73"/>
-                </a:solidFill>
-                <a:latin typeface="Roboto"/>
-                <a:cs typeface="Roboto"/>
-              </a:rPr>
-              <a:t>FCCID</a:t>
-            </a:r>
-            <a:endParaRPr sz="2400" kern="0">
-              <a:solidFill>
-                <a:sysClr val="windowText" lastClr="000000"/>
-              </a:solidFill>
-              <a:latin typeface="Roboto"/>
-              <a:cs typeface="Roboto"/>
-            </a:endParaRPr>
-          </a:p>
-        </p:txBody>
-      </p:sp>
-      <p:sp>
-        <p:nvSpPr>
-          <p:cNvPr id="15" name="object 15"/>
-          <p:cNvSpPr txBox="1"/>
-          <p:nvPr/>
-        </p:nvSpPr>
-        <p:spPr>
-          <a:xfrm>
-            <a:off x="11377941" y="6320327"/>
-            <a:ext cx="298027" cy="282129"/>
-          </a:xfrm>
-          <a:prstGeom prst="rect">
-            <a:avLst/>
-          </a:prstGeom>
-        </p:spPr>
-        <p:txBody>
-          <a:bodyPr vert="horz" wrap="square" lIns="0" tIns="0" rIns="0" bIns="0" rtlCol="0">
-            <a:spAutoFit/>
-          </a:bodyPr>
-          <a:lstStyle/>
-          <a:p>
-            <a:pPr marL="16933" defTabSz="1219170">
-              <a:lnSpc>
-                <a:spcPts val="2193"/>
-              </a:lnSpc>
-            </a:pPr>
-            <a:r>
-              <a:rPr sz="1867" kern="0" spc="-33" dirty="0">
-                <a:solidFill>
-                  <a:srgbClr val="434343"/>
-                </a:solidFill>
-                <a:latin typeface="Arial"/>
-                <a:cs typeface="Arial"/>
-              </a:rPr>
-              <a:t>38</a:t>
-            </a:r>
-            <a:endParaRPr sz="1867" kern="0">
-              <a:solidFill>
-                <a:sysClr val="windowText" lastClr="000000"/>
-              </a:solidFill>
-              <a:latin typeface="Arial"/>
-              <a:cs typeface="Arial"/>
-            </a:endParaRPr>
-          </a:p>
-        </p:txBody>
-      </p:sp>
-    </p:spTree>
-    <p:custDataLst>
-      <p:tags r:id="rId1"/>
-    </p:custDataLst>
-  </p:cSld>
-  <p:clrMapOvr>
-    <a:masterClrMapping/>
-  </p:clrMapOvr>
-</p:sld>
-</file>
-
 <file path=ppt/tags/tag1.xml><?xml version="1.0" encoding="utf-8"?>
 <p:tagLst xmlns:a="http://schemas.openxmlformats.org/drawingml/2006/main" xmlns:r="http://schemas.openxmlformats.org/officeDocument/2006/relationships" xmlns:p="http://schemas.openxmlformats.org/presentationml/2006/main">
   <p:tag name="ARTICULATE_PROJECT_OPEN" val="0"/>
   <p:tag name="ARTICULATE_SLIDE_COUNT" val="155"/>
-</p:tagLst>
-</file>
-
-<file path=ppt/tags/tag2.xml><?xml version="1.0" encoding="utf-8"?>
-<p:tagLst xmlns:a="http://schemas.openxmlformats.org/drawingml/2006/main" xmlns:r="http://schemas.openxmlformats.org/officeDocument/2006/relationships" xmlns:p="http://schemas.openxmlformats.org/presentationml/2006/main">
-  <p:tag name="ARTICULATE_SLIDE_THUMBNAIL_REFRESH" val="1"/>
-</p:tagLst>
-</file>
-
-<file path=ppt/tags/tag3.xml><?xml version="1.0" encoding="utf-8"?>
-<p:tagLst xmlns:a="http://schemas.openxmlformats.org/drawingml/2006/main" xmlns:r="http://schemas.openxmlformats.org/officeDocument/2006/relationships" xmlns:p="http://schemas.openxmlformats.org/presentationml/2006/main">
-  <p:tag name="ARTICULATE_SLIDE_THUMBNAIL_REFRESH" val="1"/>
-</p:tagLst>
-</file>
-
-<file path=ppt/tags/tag4.xml><?xml version="1.0" encoding="utf-8"?>
-<p:tagLst xmlns:a="http://schemas.openxmlformats.org/drawingml/2006/main" xmlns:r="http://schemas.openxmlformats.org/officeDocument/2006/relationships" xmlns:p="http://schemas.openxmlformats.org/presentationml/2006/main">
-  <p:tag name="ARTICULATE_SLIDE_THUMBNAIL_REFRESH" val="1"/>
 </p:tagLst>
 </file>
 
@@ -10256,6 +7186,15 @@
 </file>
 
 <file path=customXml/item1.xml><?xml version="1.0" encoding="utf-8"?>
+<?mso-contentType ?>
+<FormTemplates xmlns="http://schemas.microsoft.com/sharepoint/v3/contenttype/forms">
+  <Display>DocumentLibraryForm</Display>
+  <Edit>DocumentLibraryForm</Edit>
+  <New>DocumentLibraryForm</New>
+</FormTemplates>
+</file>
+
+<file path=customXml/item2.xml><?xml version="1.0" encoding="utf-8"?>
 <ct:contentTypeSchema xmlns:ct="http://schemas.microsoft.com/office/2006/metadata/contentType" xmlns:ma="http://schemas.microsoft.com/office/2006/metadata/properties/metaAttributes" ct:_="" ma:_="" ma:contentTypeName="Document" ma:contentTypeID="0x01010067B86F8708159745A0B6896184DE9576" ma:contentTypeVersion="19" ma:contentTypeDescription="Create a new document." ma:contentTypeScope="" ma:versionID="493bf26d373952ea1ae3b9e24cd19b33">
   <xsd:schema xmlns:xsd="http://www.w3.org/2001/XMLSchema" xmlns:xs="http://www.w3.org/2001/XMLSchema" xmlns:p="http://schemas.microsoft.com/office/2006/metadata/properties" xmlns:ns2="c7a77415-c4a3-4262-8430-671f3e8707b6" xmlns:ns3="69a7259e-7a2c-42d5-bc84-25eccf0dce8b" targetNamespace="http://schemas.microsoft.com/office/2006/metadata/properties" ma:root="true" ma:fieldsID="69c00e31f84d56e19bb090b7ea67ab52" ns2:_="" ns3:_="">
     <xsd:import namespace="c7a77415-c4a3-4262-8430-671f3e8707b6"/>
@@ -10541,16 +7480,23 @@
 </ct:contentTypeSchema>
 </file>
 
-<file path=customXml/item2.xml><?xml version="1.0" encoding="utf-8"?>
-<?mso-contentType ?>
-<FormTemplates xmlns="http://schemas.microsoft.com/sharepoint/v3/contenttype/forms">
-  <Display>DocumentLibraryForm</Display>
-  <Edit>DocumentLibraryForm</Edit>
-  <New>DocumentLibraryForm</New>
-</FormTemplates>
+<file path=customXml/item3.xml><?xml version="1.0" encoding="utf-8"?>
+<p:properties xmlns:p="http://schemas.microsoft.com/office/2006/metadata/properties" xmlns:xsi="http://www.w3.org/2001/XMLSchema-instance" xmlns:pc="http://schemas.microsoft.com/office/infopath/2007/PartnerControls">
+  <documentManagement>
+    <_dlc_DocId xmlns="c7a77415-c4a3-4262-8430-671f3e8707b6">7J4PPY27XH2W-901365475-257158</_dlc_DocId>
+    <_dlc_DocIdUrl xmlns="c7a77415-c4a3-4262-8430-671f3e8707b6">
+      <Url>https://automotivei.sharepoint.com/sites/PMO/_layouts/15/DocIdRedir.aspx?ID=7J4PPY27XH2W-901365475-257158</Url>
+      <Description>7J4PPY27XH2W-901365475-257158</Description>
+    </_dlc_DocIdUrl>
+    <TaxCatchAll xmlns="c7a77415-c4a3-4262-8430-671f3e8707b6" xsi:nil="true"/>
+    <lcf76f155ced4ddcb4097134ff3c332f xmlns="69a7259e-7a2c-42d5-bc84-25eccf0dce8b">
+      <Terms xmlns="http://schemas.microsoft.com/office/infopath/2007/PartnerControls"/>
+    </lcf76f155ced4ddcb4097134ff3c332f>
+  </documentManagement>
+</p:properties>
 </file>
 
-<file path=customXml/item3.xml><?xml version="1.0" encoding="utf-8"?>
+<file path=customXml/item4.xml><?xml version="1.0" encoding="utf-8"?>
 <?mso-contentType ?>
 <spe:Receivers xmlns:spe="http://schemas.microsoft.com/sharepoint/events">
   <Receiver>
@@ -10600,23 +7546,15 @@
 </spe:Receivers>
 </file>
 
-<file path=customXml/item4.xml><?xml version="1.0" encoding="utf-8"?>
-<p:properties xmlns:p="http://schemas.microsoft.com/office/2006/metadata/properties" xmlns:xsi="http://www.w3.org/2001/XMLSchema-instance" xmlns:pc="http://schemas.microsoft.com/office/infopath/2007/PartnerControls">
-  <documentManagement>
-    <_dlc_DocId xmlns="c7a77415-c4a3-4262-8430-671f3e8707b6">7J4PPY27XH2W-901365475-257158</_dlc_DocId>
-    <_dlc_DocIdUrl xmlns="c7a77415-c4a3-4262-8430-671f3e8707b6">
-      <Url>https://automotivei.sharepoint.com/sites/PMO/_layouts/15/DocIdRedir.aspx?ID=7J4PPY27XH2W-901365475-257158</Url>
-      <Description>7J4PPY27XH2W-901365475-257158</Description>
-    </_dlc_DocIdUrl>
-    <TaxCatchAll xmlns="c7a77415-c4a3-4262-8430-671f3e8707b6" xsi:nil="true"/>
-    <lcf76f155ced4ddcb4097134ff3c332f xmlns="69a7259e-7a2c-42d5-bc84-25eccf0dce8b">
-      <Terms xmlns="http://schemas.microsoft.com/office/infopath/2007/PartnerControls"/>
-    </lcf76f155ced4ddcb4097134ff3c332f>
-  </documentManagement>
-</p:properties>
+<file path=customXml/itemProps1.xml><?xml version="1.0" encoding="utf-8"?>
+<ds:datastoreItem xmlns:ds="http://schemas.openxmlformats.org/officeDocument/2006/customXml" ds:itemID="{84EE72F3-C956-4A5B-833F-E761B5D8ACD8}">
+  <ds:schemaRefs>
+    <ds:schemaRef ds:uri="http://schemas.microsoft.com/sharepoint/v3/contenttype/forms"/>
+  </ds:schemaRefs>
+</ds:datastoreItem>
 </file>
 
-<file path=customXml/itemProps1.xml><?xml version="1.0" encoding="utf-8"?>
+<file path=customXml/itemProps2.xml><?xml version="1.0" encoding="utf-8"?>
 <ds:datastoreItem xmlns:ds="http://schemas.openxmlformats.org/officeDocument/2006/customXml" ds:itemID="{8FEF19B7-7529-453B-A7D5-A8465340F17A}">
   <ds:schemaRefs>
     <ds:schemaRef ds:uri="http://schemas.microsoft.com/office/2006/metadata/contentType"/>
@@ -10635,23 +7573,7 @@
 </ds:datastoreItem>
 </file>
 
-<file path=customXml/itemProps2.xml><?xml version="1.0" encoding="utf-8"?>
-<ds:datastoreItem xmlns:ds="http://schemas.openxmlformats.org/officeDocument/2006/customXml" ds:itemID="{84EE72F3-C956-4A5B-833F-E761B5D8ACD8}">
-  <ds:schemaRefs>
-    <ds:schemaRef ds:uri="http://schemas.microsoft.com/sharepoint/v3/contenttype/forms"/>
-  </ds:schemaRefs>
-</ds:datastoreItem>
-</file>
-
 <file path=customXml/itemProps3.xml><?xml version="1.0" encoding="utf-8"?>
-<ds:datastoreItem xmlns:ds="http://schemas.openxmlformats.org/officeDocument/2006/customXml" ds:itemID="{54C592EF-85C1-482B-896B-DED434B6FCCC}">
-  <ds:schemaRefs>
-    <ds:schemaRef ds:uri="http://schemas.microsoft.com/sharepoint/events"/>
-  </ds:schemaRefs>
-</ds:datastoreItem>
-</file>
-
-<file path=customXml/itemProps4.xml><?xml version="1.0" encoding="utf-8"?>
 <ds:datastoreItem xmlns:ds="http://schemas.openxmlformats.org/officeDocument/2006/customXml" ds:itemID="{E71A463F-9F4B-47AC-91AA-3962FD8F3CE5}">
   <ds:schemaRefs>
     <ds:schemaRef ds:uri="http://schemas.microsoft.com/office/2006/metadata/properties"/>
@@ -10660,4 +7582,12 @@
     <ds:schemaRef ds:uri="69a7259e-7a2c-42d5-bc84-25eccf0dce8b"/>
   </ds:schemaRefs>
 </ds:datastoreItem>
+</file>
+
+<file path=customXml/itemProps4.xml><?xml version="1.0" encoding="utf-8"?>
+<ds:datastoreItem xmlns:ds="http://schemas.openxmlformats.org/officeDocument/2006/customXml" ds:itemID="{54C592EF-85C1-482B-896B-DED434B6FCCC}">
+  <ds:schemaRefs>
+    <ds:schemaRef ds:uri="http://schemas.microsoft.com/sharepoint/events"/>
+  </ds:schemaRefs>
+</ds:datastoreItem>
 </file>
</xml_diff>